<commit_message>
add notebook with fixed dataset
</commit_message>
<xml_diff>
--- a/TP_Grupal_slides.pptx
+++ b/TP_Grupal_slides.pptx
@@ -6,8 +6,9 @@
   </p:sldMasterIdLst>
   <p:sldIdLst>
     <p:sldId id="256" r:id="rId7"/>
+    <p:sldId id="258" r:id="rId9"/>
     <p:sldId id="257" r:id="rId8"/>
-    <p:sldId id="258" r:id="rId9"/>
+    <p:sldId id="259" r:id="rId10"/>
   </p:sldIdLst>
   <p:sldSz cx="12191695" cy="6858000" type="screen4x3"/>
   <p:notesSz cx="6858000" cy="9144000"/>
@@ -3164,7 +3165,7 @@
                 </a:solidFill>
                 <a:latin typeface="Arial"/>
               </a:rPr>
-              <a:t>Dataset de películas IMDB</a:t>
+              <a:t>EDA — TMDB Movies Dataset 2023</a:t>
             </a:r>
           </a:p>
         </p:txBody>
@@ -3199,7 +3200,7 @@
                 </a:solidFill>
                 <a:latin typeface="Arial"/>
               </a:rPr>
-              <a:t>Base pública de 117 films con datos de crítica, votos y taquilla.</a:t>
+              <a:t>Análisis exploratorio y preparación de datos (Clases 3–4) · EDA puro, sin variable target</a:t>
             </a:r>
           </a:p>
         </p:txBody>
@@ -3272,13 +3273,13 @@
           <a:p>
             <a:pPr algn="l"/>
             <a:r>
-              <a:rPr sz="3400" b="1">
+              <a:rPr sz="2100" b="1">
                 <a:solidFill>
                   <a:srgbClr val="0F766E"/>
                 </a:solidFill>
                 <a:latin typeface="Arial"/>
               </a:rPr>
-              <a:t>117</a:t>
+              <a:t>1.499.934</a:t>
             </a:r>
           </a:p>
         </p:txBody>
@@ -3392,7 +3393,7 @@
                 </a:solidFill>
                 <a:latin typeface="Arial"/>
               </a:rPr>
-              <a:t>54</a:t>
+              <a:t>24</a:t>
             </a:r>
           </a:p>
         </p:txBody>
@@ -3506,7 +3507,7 @@
                 </a:solidFill>
                 <a:latin typeface="Arial"/>
               </a:rPr>
-              <a:t>20</a:t>
+              <a:t>19</a:t>
             </a:r>
           </a:p>
         </p:txBody>
@@ -3620,7 +3621,7 @@
                 </a:solidFill>
                 <a:latin typeface="Arial"/>
               </a:rPr>
-              <a:t>7.9</a:t>
+              <a:t>6.16</a:t>
             </a:r>
           </a:p>
         </p:txBody>
@@ -3734,7 +3735,7 @@
                 </a:solidFill>
                 <a:latin typeface="Arial"/>
               </a:rPr>
-              <a:t>Estructura</a:t>
+              <a:t>El dataset</a:t>
             </a:r>
           </a:p>
         </p:txBody>
@@ -3761,63 +3762,83 @@
           </a:bodyPr>
           <a:lstStyle/>
           <a:p>
-            <a:pPr algn="l"/>
-            <a:r>
-              <a:rPr sz="1350" b="0">
+            <a:pPr algn="l">
+              <a:spcAft>
+                <a:spcPts val="600"/>
+              </a:spcAft>
+            </a:pPr>
+            <a:r>
+              <a:rPr sz="1300">
                 <a:solidFill>
                   <a:srgbClr val="1D2433"/>
                 </a:solidFill>
                 <a:latin typeface="Arial"/>
               </a:rPr>
-              <a:t>3 tablas relacionadas por Movie_id:</a:t>
-            </a:r>
-          </a:p>
-          <a:p>
-            <a:pPr algn="l"/>
-            <a:r>
-              <a:rPr sz="1350" b="0">
+              <a:t>TMDB Movies 2023 (fuente pública, Kaggle).</a:t>
+            </a:r>
+          </a:p>
+          <a:p>
+            <a:pPr>
+              <a:spcAft>
+                <a:spcPts val="600"/>
+              </a:spcAft>
+            </a:pPr>
+            <a:r>
+              <a:rPr sz="1300">
                 <a:solidFill>
                   <a:srgbClr val="1D2433"/>
                 </a:solidFill>
                 <a:latin typeface="Arial"/>
               </a:rPr>
-              <a:t>• IMDB — rating, votos, presupuesto, duración</a:t>
-            </a:r>
-          </a:p>
-          <a:p>
-            <a:pPr algn="l"/>
-            <a:r>
-              <a:rPr sz="1350" b="0">
+              <a:t>Granularidad: 1 fila = 1 película, unidas por id.</a:t>
+            </a:r>
+          </a:p>
+          <a:p>
+            <a:pPr>
+              <a:spcAft>
+                <a:spcPts val="600"/>
+              </a:spcAft>
+            </a:pPr>
+            <a:r>
+              <a:rPr sz="1300">
                 <a:solidFill>
                   <a:srgbClr val="1D2433"/>
                 </a:solidFill>
                 <a:latin typeface="Arial"/>
               </a:rPr>
-              <a:t>• earning — recaudación local y mundial</a:t>
-            </a:r>
-          </a:p>
-          <a:p>
-            <a:pPr algn="l"/>
-            <a:r>
-              <a:rPr sz="1350" b="0">
+              <a:t>Numéricas: budget, revenue, runtime, votos, popularity.</a:t>
+            </a:r>
+          </a:p>
+          <a:p>
+            <a:pPr>
+              <a:spcAft>
+                <a:spcPts val="600"/>
+              </a:spcAft>
+            </a:pPr>
+            <a:r>
+              <a:rPr sz="1300">
                 <a:solidFill>
                   <a:srgbClr val="1D2433"/>
                 </a:solidFill>
                 <a:latin typeface="Arial"/>
               </a:rPr>
-              <a:t>• genre — género (relación 1-a-muchos)</a:t>
-            </a:r>
-          </a:p>
-          <a:p>
-            <a:pPr algn="l"/>
-            <a:r>
-              <a:rPr sz="1350" b="0">
+              <a:t>Categóricas: género, idioma, estado.</a:t>
+            </a:r>
+          </a:p>
+          <a:p>
+            <a:pPr>
+              <a:spcAft>
+                <a:spcPts val="600"/>
+              </a:spcAft>
+            </a:pPr>
+            <a:r>
+              <a:rPr sz="1300">
                 <a:solidFill>
                   <a:srgbClr val="1D2433"/>
                 </a:solidFill>
                 <a:latin typeface="Arial"/>
               </a:rPr>
-              <a:t>Variables numéricas + categóricas (título, género).</a:t>
+              <a:t>genres: multivariado, coma-separado (1-a-muchos).</a:t>
             </a:r>
           </a:p>
         </p:txBody>
@@ -3923,63 +3944,67 @@
           </a:bodyPr>
           <a:lstStyle/>
           <a:p>
-            <a:pPr algn="l"/>
-            <a:r>
-              <a:rPr sz="1250" b="0">
+            <a:pPr algn="l">
+              <a:spcAft>
+                <a:spcPts val="600"/>
+              </a:spcAft>
+            </a:pPr>
+            <a:r>
+              <a:rPr sz="1300">
                 <a:solidFill>
                   <a:srgbClr val="1D2433"/>
                 </a:solidFill>
                 <a:latin typeface="Arial"/>
               </a:rPr>
-              <a:t>• 54 variables, pero 45 son desgloses de votos por demografía → alta dimensionalidad</a:t>
-            </a:r>
-          </a:p>
-          <a:p>
-            <a:pPr algn="l"/>
-            <a:r>
-              <a:rPr sz="1250" b="0">
+              <a:t>Escala: 1,5 M de filas → cómputo vectorizado sobre el total.</a:t>
+            </a:r>
+          </a:p>
+          <a:p>
+            <a:pPr>
+              <a:spcAft>
+                <a:spcPts val="600"/>
+              </a:spcAft>
+            </a:pPr>
+            <a:r>
+              <a:rPr sz="1300">
                 <a:solidFill>
                   <a:srgbClr val="1D2433"/>
                 </a:solidFill>
                 <a:latin typeface="Arial"/>
               </a:rPr>
-              <a:t>• Columnas numéricas guardadas como texto (Runtime '134 min', Budget, MetaCritic)</a:t>
-            </a:r>
-          </a:p>
-          <a:p>
-            <a:pPr algn="l"/>
-            <a:r>
-              <a:rPr sz="1250" b="0">
+              <a:t>Nulos masivos: revenue 98%, budget 94%.</a:t>
+            </a:r>
+          </a:p>
+          <a:p>
+            <a:pPr>
+              <a:spcAft>
+                <a:spcPts val="600"/>
+              </a:spcAft>
+            </a:pPr>
+            <a:r>
+              <a:rPr sz="1300">
                 <a:solidFill>
                   <a:srgbClr val="1D2433"/>
                 </a:solidFill>
                 <a:latin typeface="Arial"/>
               </a:rPr>
-              <a:t>• Nulos: Runtime 21, MetaCritic 7, Budget 3</a:t>
-            </a:r>
-          </a:p>
-          <a:p>
-            <a:pPr algn="l"/>
-            <a:r>
-              <a:rPr sz="1250" b="0">
+              <a:t>Centinelas (0 / negativos) que codifican 'sin dato'.</a:t>
+            </a:r>
+          </a:p>
+          <a:p>
+            <a:pPr>
+              <a:spcAft>
+                <a:spcPts val="600"/>
+              </a:spcAft>
+            </a:pPr>
+            <a:r>
+              <a:rPr sz="1300">
                 <a:solidFill>
                   <a:srgbClr val="1D2433"/>
                 </a:solidFill>
                 <a:latin typeface="Arial"/>
               </a:rPr>
-              <a:t>• 41 filas con género vacío</a:t>
-            </a:r>
-          </a:p>
-          <a:p>
-            <a:pPr algn="l"/>
-            <a:r>
-              <a:rPr sz="1250" b="0">
-                <a:solidFill>
-                  <a:srgbClr val="1D2433"/>
-                </a:solidFill>
-                <a:latin typeface="Arial"/>
-              </a:rPr>
-              <a:t>• Hay que unir 3 tablas para el análisis</a:t>
+              <a:t>Fuerte presencia de outliers: colas largas en budget, revenue, vote_count y popularity (asimetría extrema).</a:t>
             </a:r>
           </a:p>
         </p:txBody>
@@ -4076,7 +4101,7 @@
                 </a:solidFill>
                 <a:latin typeface="Arial"/>
               </a:rPr>
-              <a:t>Qué nos dicen los datos</a:t>
+              <a:t>Calidad de datos: faltantes y su mecanismo</a:t>
             </a:r>
           </a:p>
         </p:txBody>
@@ -4111,107 +4136,216 @@
                 </a:solidFill>
                 <a:latin typeface="Arial"/>
               </a:rPr>
-              <a:t>Rating promedio 7.9  ·  género top: Drama  ·  más votada: Inception (2010)</a:t>
+              <a:t>Centinelas (0 / negativos) marcados como NaN antes de analizar</a:t>
             </a:r>
           </a:p>
         </p:txBody>
       </p:sp>
       <p:pic>
         <p:nvPicPr>
-          <p:cNvPr id="5" name="Picture 4" descr="rating.png"/>
+          <p:cNvPr id="5" name="Picture 4" descr="nulos.png"/>
           <p:cNvPicPr>
             <a:picLocks noChangeAspect="1"/>
           </p:cNvPicPr>
           <p:nvPr/>
         </p:nvPicPr>
         <p:blipFill>
-          <a:blip r:embed="rId2"/>
+          <a:blip r:embed="rId6"/>
           <a:stretch>
             <a:fillRect/>
           </a:stretch>
         </p:blipFill>
         <p:spPr>
           <a:xfrm>
-            <a:off x="548640" y="1600200"/>
-            <a:ext cx="5303520" cy="3847194"/>
+            <a:off x="548640" y="2459935"/>
+            <a:ext cx="5486400" cy="3126849"/>
           </a:xfrm>
           <a:prstGeom prst="rect">
             <a:avLst/>
           </a:prstGeom>
         </p:spPr>
       </p:pic>
-      <p:pic>
-        <p:nvPicPr>
-          <p:cNvPr id="6" name="Picture 5" descr="genres.png"/>
-          <p:cNvPicPr>
-            <a:picLocks noChangeAspect="1"/>
-          </p:cNvPicPr>
+      <p:sp>
+        <p:nvSpPr>
+          <p:cNvPr id="6" name="Rounded Rectangle 5"/>
+          <p:cNvSpPr/>
           <p:nvPr/>
-        </p:nvPicPr>
-        <p:blipFill>
-          <a:blip r:embed="rId3"/>
-          <a:stretch>
-            <a:fillRect/>
-          </a:stretch>
-        </p:blipFill>
-        <p:spPr>
-          <a:xfrm>
-            <a:off x="6355080" y="1600200"/>
-            <a:ext cx="5303520" cy="3411379"/>
+        </p:nvSpPr>
+        <p:spPr>
+          <a:xfrm>
+            <a:off x="6492240" y="1737360"/>
+            <a:ext cx="5212080" cy="4572000"/>
+          </a:xfrm>
+          <a:prstGeom prst="roundRect">
+            <a:avLst/>
+          </a:prstGeom>
+          <a:solidFill>
+            <a:srgbClr val="F1F5F9"/>
+          </a:solidFill>
+          <a:ln>
+            <a:noFill/>
+          </a:ln>
+          <a:effectLst/>
+        </p:spPr>
+        <p:style>
+          <a:lnRef idx="1">
+            <a:schemeClr val="accent1"/>
+          </a:lnRef>
+          <a:fillRef idx="3">
+            <a:schemeClr val="accent1"/>
+          </a:fillRef>
+          <a:effectRef idx="2">
+            <a:schemeClr val="accent1"/>
+          </a:effectRef>
+          <a:fontRef idx="minor">
+            <a:schemeClr val="lt1"/>
+          </a:fontRef>
+        </p:style>
+        <p:txBody>
+          <a:bodyPr rtlCol="0" anchor="ctr"/>
+          <a:lstStyle/>
+          <a:p>
+            <a:pPr algn="ctr"/>
+          </a:p>
+        </p:txBody>
+      </p:sp>
+      <p:sp>
+        <p:nvSpPr>
+          <p:cNvPr id="7" name="TextBox 6"/>
+          <p:cNvSpPr txBox="1"/>
+          <p:nvPr/>
+        </p:nvSpPr>
+        <p:spPr>
+          <a:xfrm>
+            <a:off x="6720840" y="1874520"/>
+            <a:ext cx="4754880" cy="457200"/>
           </a:xfrm>
           <a:prstGeom prst="rect">
             <a:avLst/>
           </a:prstGeom>
-        </p:spPr>
-      </p:pic>
-      <p:pic>
-        <p:nvPicPr>
-          <p:cNvPr id="7" name="Picture 6" descr="scatter.png"/>
-          <p:cNvPicPr>
-            <a:picLocks noChangeAspect="1"/>
-          </p:cNvPicPr>
+          <a:noFill/>
+        </p:spPr>
+        <p:txBody>
+          <a:bodyPr wrap="square">
+            <a:spAutoFit/>
+          </a:bodyPr>
+          <a:lstStyle/>
+          <a:p>
+            <a:r>
+              <a:rPr sz="1900" b="1">
+                <a:solidFill>
+                  <a:srgbClr val="0F766E"/>
+                </a:solidFill>
+                <a:latin typeface="Arial"/>
+              </a:rPr>
+              <a:t>Mecanismos de faltantes</a:t>
+            </a:r>
+          </a:p>
+        </p:txBody>
+      </p:sp>
+      <p:sp>
+        <p:nvSpPr>
+          <p:cNvPr id="8" name="TextBox 7"/>
+          <p:cNvSpPr txBox="1"/>
           <p:nvPr/>
-        </p:nvPicPr>
-        <p:blipFill>
-          <a:blip r:embed="rId4"/>
-          <a:stretch>
-            <a:fillRect/>
-          </a:stretch>
-        </p:blipFill>
-        <p:spPr>
-          <a:xfrm>
-            <a:off x="548640" y="4206240"/>
-            <a:ext cx="5303520" cy="3837569"/>
+        </p:nvSpPr>
+        <p:spPr>
+          <a:xfrm>
+            <a:off x="6720840" y="2468880"/>
+            <a:ext cx="4754880" cy="3703320"/>
           </a:xfrm>
           <a:prstGeom prst="rect">
             <a:avLst/>
           </a:prstGeom>
-        </p:spPr>
-      </p:pic>
-      <p:pic>
-        <p:nvPicPr>
-          <p:cNvPr id="8" name="Picture 7" descr="box.png"/>
-          <p:cNvPicPr>
-            <a:picLocks noChangeAspect="1"/>
-          </p:cNvPicPr>
-          <p:nvPr/>
-        </p:nvPicPr>
-        <p:blipFill>
-          <a:blip r:embed="rId5"/>
-          <a:stretch>
-            <a:fillRect/>
-          </a:stretch>
-        </p:blipFill>
-        <p:spPr>
-          <a:xfrm>
-            <a:off x="6355080" y="4206240"/>
-            <a:ext cx="5303520" cy="3338183"/>
-          </a:xfrm>
-          <a:prstGeom prst="rect">
-            <a:avLst/>
-          </a:prstGeom>
-        </p:spPr>
-      </p:pic>
+          <a:noFill/>
+        </p:spPr>
+        <p:txBody>
+          <a:bodyPr wrap="square">
+            <a:spAutoFit/>
+          </a:bodyPr>
+          <a:lstStyle/>
+          <a:p>
+            <a:pPr>
+              <a:spcAft>
+                <a:spcPts val="600"/>
+              </a:spcAft>
+            </a:pPr>
+            <a:r>
+              <a:rPr sz="1250">
+                <a:solidFill>
+                  <a:srgbClr val="1D2433"/>
+                </a:solidFill>
+                <a:latin typeface="Arial"/>
+              </a:rPr>
+              <a:t>runtime ~32%: MCAR/MAR → imputable por mediana (fit en train).</a:t>
+            </a:r>
+          </a:p>
+          <a:p>
+            <a:pPr>
+              <a:spcAft>
+                <a:spcPts val="600"/>
+              </a:spcAft>
+            </a:pPr>
+            <a:r>
+              <a:rPr sz="1250">
+                <a:solidFill>
+                  <a:srgbClr val="1D2433"/>
+                </a:solidFill>
+                <a:latin typeface="Arial"/>
+              </a:rPr>
+              <a:t>budget 94% / revenue 98%: estructural → no se imputan; se agrega indicador tiene_budget / tiene_revenue.</a:t>
+            </a:r>
+          </a:p>
+          <a:p>
+            <a:pPr>
+              <a:spcAft>
+                <a:spcPts val="600"/>
+              </a:spcAft>
+            </a:pPr>
+            <a:r>
+              <a:rPr sz="1250">
+                <a:solidFill>
+                  <a:srgbClr val="1D2433"/>
+                </a:solidFill>
+                <a:latin typeface="Arial"/>
+              </a:rPr>
+              <a:t>vote_average 76%: falta exactamente cuando vote_count = 0 (estructural).</a:t>
+            </a:r>
+          </a:p>
+          <a:p>
+            <a:pPr>
+              <a:spcAft>
+                <a:spcPts val="600"/>
+              </a:spcAft>
+            </a:pPr>
+            <a:r>
+              <a:rPr sz="1250">
+                <a:solidFill>
+                  <a:srgbClr val="1D2433"/>
+                </a:solidFill>
+                <a:latin typeface="Arial"/>
+              </a:rPr>
+              <a:t>genres 45%: se marca con categoría propia 'SIN_GÉNERO'.</a:t>
+            </a:r>
+          </a:p>
+          <a:p>
+            <a:pPr>
+              <a:spcAft>
+                <a:spcPts val="600"/>
+              </a:spcAft>
+            </a:pPr>
+            <a:r>
+              <a:rPr sz="1250">
+                <a:solidFill>
+                  <a:srgbClr val="1D2433"/>
+                </a:solidFill>
+                <a:latin typeface="Arial"/>
+              </a:rPr>
+              <a:t>Regla &gt;70% nulos → no se imputa la columna.</a:t>
+            </a:r>
+          </a:p>
+        </p:txBody>
+      </p:sp>
     </p:spTree>
   </p:cSld>
   <p:clrMapOvr>
@@ -4304,7 +4438,7 @@
                 </a:solidFill>
                 <a:latin typeface="Arial"/>
               </a:rPr>
-              <a:t>Relaciones entre variables</a:t>
+              <a:t>Asociaciones y pruebas de hipótesis</a:t>
             </a:r>
           </a:p>
         </p:txBody>
@@ -4339,35 +4473,11 @@
                 </a:solidFill>
                 <a:latin typeface="Arial"/>
               </a:rPr>
-              <a:t>El dinero genera dinero, pero no calidad: la calidad depende de lo creativo.</a:t>
-            </a:r>
-          </a:p>
-        </p:txBody>
-      </p:sp>
-      <p:pic>
-        <p:nvPicPr>
-          <p:cNvPr id="5" name="Picture 4" descr="corr_full.png"/>
-          <p:cNvPicPr>
-            <a:picLocks noChangeAspect="1"/>
-          </p:cNvPicPr>
-          <p:nvPr/>
-        </p:nvPicPr>
-        <p:blipFill>
-          <a:blip r:embed="rId2"/>
-          <a:stretch>
-            <a:fillRect/>
-          </a:stretch>
-        </p:blipFill>
-        <p:spPr>
-          <a:xfrm>
-            <a:off x="548640" y="1737360"/>
-            <a:ext cx="5312229" cy="4572000"/>
-          </a:xfrm>
-          <a:prstGeom prst="rect">
-            <a:avLst/>
-          </a:prstGeom>
-        </p:spPr>
-      </p:pic>
+              <a:t>Asociación, no causalidad · Pearson (lineal) y Spearman (monótona) · α = 0.05</a:t>
+            </a:r>
+          </a:p>
+        </p:txBody>
+      </p:sp>
       <p:sp>
         <p:nvSpPr>
           <p:cNvPr id="6" name="Rounded Rectangle 5"/>
@@ -4442,7 +4552,7 @@
                 </a:solidFill>
                 <a:latin typeface="Arial"/>
               </a:rPr>
-              <a:t>Qué nos dice</a:t>
+              <a:t>Pruebas de hipótesis</a:t>
             </a:r>
           </a:p>
         </p:txBody>
@@ -4469,75 +4579,490 @@
           </a:bodyPr>
           <a:lstStyle/>
           <a:p>
-            <a:pPr algn="l"/>
-            <a:r>
-              <a:rPr sz="1400" b="0">
+            <a:pPr algn="l">
+              <a:spcAft>
+                <a:spcPts val="600"/>
+              </a:spcAft>
+            </a:pPr>
+            <a:r>
+              <a:rPr sz="1250">
                 <a:solidFill>
                   <a:srgbClr val="1D2433"/>
                 </a:solidFill>
                 <a:latin typeface="Arial"/>
               </a:rPr>
-              <a:t>• Si inviertes MÁS dinero, GANÁS más dinero.</a:t>
-            </a:r>
-          </a:p>
-          <a:p>
-            <a:pPr algn="l"/>
-            <a:r>
-              <a:rPr sz="1400" b="0">
+              <a:t>H0: r = 0 (sin asociación) · H1: r ≠ 0.</a:t>
+            </a:r>
+          </a:p>
+          <a:p>
+            <a:pPr>
+              <a:spcAft>
+                <a:spcPts val="600"/>
+              </a:spcAft>
+            </a:pPr>
+            <a:r>
+              <a:rPr sz="1250">
                 <a:solidFill>
                   <a:srgbClr val="1D2433"/>
                 </a:solidFill>
                 <a:latin typeface="Arial"/>
               </a:rPr>
-              <a:t>• Más presupuesto NO implica mejor calificación.</a:t>
-            </a:r>
-          </a:p>
-          <a:p>
-            <a:pPr algn="l"/>
-            <a:r>
-              <a:rPr sz="1400" b="0">
+              <a:t>Los 5 pares dan p &lt; 0.001 (≪ α): se rechaza H0 en todos → asociación estadísticamente significativa.</a:t>
+            </a:r>
+          </a:p>
+          <a:p>
+            <a:pPr>
+              <a:spcAft>
+                <a:spcPts val="600"/>
+              </a:spcAft>
+            </a:pPr>
+            <a:r>
+              <a:rPr sz="1250">
                 <a:solidFill>
                   <a:srgbClr val="1D2433"/>
                 </a:solidFill>
                 <a:latin typeface="Arial"/>
               </a:rPr>
-              <a:t>• Ganar más dinero NO implica mejor película.</a:t>
-            </a:r>
-          </a:p>
-          <a:p>
-            <a:pPr algn="l"/>
-            <a:r>
-              <a:rPr sz="1400" b="0">
+              <a:t>La más fuerte: budget–revenue (Spearman 0.90, Pearson 0.56: la asimetría hace que Pearson la subestime).</a:t>
+            </a:r>
+          </a:p>
+          <a:p>
+            <a:pPr>
+              <a:spcAft>
+                <a:spcPts val="600"/>
+              </a:spcAft>
+            </a:pPr>
+            <a:r>
+              <a:rPr sz="1250">
                 <a:solidFill>
                   <a:srgbClr val="1D2433"/>
                 </a:solidFill>
                 <a:latin typeface="Arial"/>
               </a:rPr>
-              <a:t>• Cuanto MÁS POPULAR, mejor calificación recibe.</a:t>
-            </a:r>
-          </a:p>
-          <a:p>
-            <a:pPr algn="l"/>
-            <a:r>
-              <a:rPr sz="1400" b="0">
+              <a:t>t-test género→vote_average: p ≈ 0 → los documentales puntúan más alto (6.76 vs 6.06).</a:t>
+            </a:r>
+          </a:p>
+          <a:p>
+            <a:pPr>
+              <a:spcAft>
+                <a:spcPts val="600"/>
+              </a:spcAft>
+            </a:pPr>
+            <a:r>
+              <a:rPr sz="1250">
                 <a:solidFill>
                   <a:srgbClr val="1D2433"/>
                 </a:solidFill>
                 <a:latin typeface="Arial"/>
               </a:rPr>
-              <a:t>• Las películas MÁS LARGAS no son mejor calificadas.</a:t>
-            </a:r>
-          </a:p>
-          <a:p>
-            <a:pPr algn="l"/>
-            <a:r>
-              <a:rPr sz="1400" b="0">
+              <a:t>Significación estadística ≠ causalidad.</a:t>
+            </a:r>
+          </a:p>
+        </p:txBody>
+      </p:sp>
+      <p:pic>
+        <p:nvPicPr>
+          <p:cNvPr id="9" name="Picture 8" descr="corr.png"/>
+          <p:cNvPicPr>
+            <a:picLocks noChangeAspect="1"/>
+          </p:cNvPicPr>
+          <p:nvPr/>
+        </p:nvPicPr>
+        <p:blipFill>
+          <a:blip r:embed="rId3"/>
+          <a:stretch>
+            <a:fillRect/>
+          </a:stretch>
+        </p:blipFill>
+        <p:spPr>
+          <a:xfrm>
+            <a:off x="457200" y="1600200"/>
+            <a:ext cx="5760720" cy="2391898"/>
+          </a:xfrm>
+          <a:prstGeom prst="rect">
+            <a:avLst/>
+          </a:prstGeom>
+        </p:spPr>
+      </p:pic>
+      <p:pic>
+        <p:nvPicPr>
+          <p:cNvPr id="10" name="Picture 9" descr="tests.png"/>
+          <p:cNvPicPr>
+            <a:picLocks noChangeAspect="1"/>
+          </p:cNvPicPr>
+          <p:nvPr/>
+        </p:nvPicPr>
+        <p:blipFill>
+          <a:blip r:embed="rId4"/>
+          <a:stretch>
+            <a:fillRect/>
+          </a:stretch>
+        </p:blipFill>
+        <p:spPr>
+          <a:xfrm>
+            <a:off x="457200" y="4114800"/>
+            <a:ext cx="5760720" cy="1672155"/>
+          </a:xfrm>
+          <a:prstGeom prst="rect">
+            <a:avLst/>
+          </a:prstGeom>
+        </p:spPr>
+      </p:pic>
+    </p:spTree>
+  </p:cSld>
+  <p:clrMapOvr>
+    <a:masterClrMapping/>
+  </p:clrMapOvr>
+</p:sld>
+</file>
+
+<file path=ppt/slides/slide4.xml><?xml version="1.0" encoding="utf-8"?>
+<p:sld xmlns:a="http://schemas.openxmlformats.org/drawingml/2006/main" xmlns:p="http://schemas.openxmlformats.org/presentationml/2006/main" xmlns:r="http://schemas.openxmlformats.org/officeDocument/2006/relationships">
+  <p:cSld>
+    <p:spTree>
+      <p:nvGrpSpPr>
+        <p:cNvPr id="1" name=""/>
+        <p:cNvGrpSpPr/>
+        <p:nvPr/>
+      </p:nvGrpSpPr>
+      <p:grpSpPr/>
+      <p:sp>
+        <p:nvSpPr>
+          <p:cNvPr id="2" name="Rectangle 1"/>
+          <p:cNvSpPr/>
+          <p:nvPr/>
+        </p:nvSpPr>
+        <p:spPr>
+          <a:xfrm>
+            <a:off x="0" y="0"/>
+            <a:ext cx="164592" cy="6858000"/>
+          </a:xfrm>
+          <a:prstGeom prst="rect">
+            <a:avLst/>
+          </a:prstGeom>
+          <a:solidFill>
+            <a:srgbClr val="0F766E"/>
+          </a:solidFill>
+          <a:ln>
+            <a:noFill/>
+          </a:ln>
+          <a:effectLst/>
+        </p:spPr>
+        <p:style>
+          <a:lnRef idx="1">
+            <a:schemeClr val="accent1"/>
+          </a:lnRef>
+          <a:fillRef idx="3">
+            <a:schemeClr val="accent1"/>
+          </a:fillRef>
+          <a:effectRef idx="2">
+            <a:schemeClr val="accent1"/>
+          </a:effectRef>
+          <a:fontRef idx="minor">
+            <a:schemeClr val="lt1"/>
+          </a:fontRef>
+        </p:style>
+        <p:txBody>
+          <a:bodyPr rtlCol="0" anchor="ctr"/>
+          <a:lstStyle/>
+          <a:p>
+            <a:pPr algn="ctr"/>
+          </a:p>
+        </p:txBody>
+      </p:sp>
+      <p:sp>
+        <p:nvSpPr>
+          <p:cNvPr id="3" name="TextBox 2"/>
+          <p:cNvSpPr txBox="1"/>
+          <p:nvPr/>
+        </p:nvSpPr>
+        <p:spPr>
+          <a:xfrm>
+            <a:off x="502920" y="320040"/>
+            <a:ext cx="10972800" cy="731520"/>
+          </a:xfrm>
+          <a:prstGeom prst="rect">
+            <a:avLst/>
+          </a:prstGeom>
+          <a:noFill/>
+        </p:spPr>
+        <p:txBody>
+          <a:bodyPr wrap="square">
+            <a:spAutoFit/>
+          </a:bodyPr>
+          <a:lstStyle/>
+          <a:p>
+            <a:r>
+              <a:rPr sz="3400" b="1">
                 <a:solidFill>
                   <a:srgbClr val="1D2433"/>
                 </a:solidFill>
                 <a:latin typeface="Arial"/>
               </a:rPr>
-              <a:t>• A mayor presupuesto, críticos MENOS entusiastas.</a:t>
+              <a:t>Géneros y conclusiones</a:t>
+            </a:r>
+          </a:p>
+        </p:txBody>
+      </p:sp>
+      <p:sp>
+        <p:nvSpPr>
+          <p:cNvPr id="4" name="TextBox 3"/>
+          <p:cNvSpPr txBox="1"/>
+          <p:nvPr/>
+        </p:nvSpPr>
+        <p:spPr>
+          <a:xfrm>
+            <a:off x="548640" y="1051560"/>
+            <a:ext cx="11155680" cy="457200"/>
+          </a:xfrm>
+          <a:prstGeom prst="rect">
+            <a:avLst/>
+          </a:prstGeom>
+          <a:noFill/>
+        </p:spPr>
+        <p:txBody>
+          <a:bodyPr wrap="square">
+            <a:spAutoFit/>
+          </a:bodyPr>
+          <a:lstStyle/>
+          <a:p>
+            <a:r>
+              <a:rPr sz="1500" b="0">
+                <a:solidFill>
+                  <a:srgbClr val="475669"/>
+                </a:solidFill>
+                <a:latin typeface="Arial"/>
+              </a:rPr>
+              <a:t>k = 19 géneros · diversidad alta (H/H_max = 0.86)</a:t>
+            </a:r>
+          </a:p>
+        </p:txBody>
+      </p:sp>
+      <p:pic>
+        <p:nvPicPr>
+          <p:cNvPr id="5" name="Picture 4" descr="generos.png"/>
+          <p:cNvPicPr>
+            <a:picLocks noChangeAspect="1"/>
+          </p:cNvPicPr>
+          <p:nvPr/>
+        </p:nvPicPr>
+        <p:blipFill>
+          <a:blip r:embed="rId2"/>
+          <a:stretch>
+            <a:fillRect/>
+          </a:stretch>
+        </p:blipFill>
+        <p:spPr>
+          <a:xfrm>
+            <a:off x="548640" y="1600200"/>
+            <a:ext cx="4846320" cy="2654497"/>
+          </a:xfrm>
+          <a:prstGeom prst="rect">
+            <a:avLst/>
+          </a:prstGeom>
+        </p:spPr>
+      </p:pic>
+      <p:pic>
+        <p:nvPicPr>
+          <p:cNvPr id="6" name="Picture 5" descr="removed.png"/>
+          <p:cNvPicPr>
+            <a:picLocks noChangeAspect="1"/>
+          </p:cNvPicPr>
+          <p:nvPr/>
+        </p:nvPicPr>
+        <p:blipFill>
+          <a:blip r:embed="rId3"/>
+          <a:stretch>
+            <a:fillRect/>
+          </a:stretch>
+        </p:blipFill>
+        <p:spPr>
+          <a:xfrm>
+            <a:off x="457200" y="4297680"/>
+            <a:ext cx="5760720" cy="1792976"/>
+          </a:xfrm>
+          <a:prstGeom prst="rect">
+            <a:avLst/>
+          </a:prstGeom>
+        </p:spPr>
+      </p:pic>
+      <p:sp>
+        <p:nvSpPr>
+          <p:cNvPr id="7" name="Rounded Rectangle 6"/>
+          <p:cNvSpPr/>
+          <p:nvPr/>
+        </p:nvSpPr>
+        <p:spPr>
+          <a:xfrm>
+            <a:off x="6492240" y="1737360"/>
+            <a:ext cx="5212080" cy="4572000"/>
+          </a:xfrm>
+          <a:prstGeom prst="roundRect">
+            <a:avLst/>
+          </a:prstGeom>
+          <a:solidFill>
+            <a:srgbClr val="F1F5F9"/>
+          </a:solidFill>
+          <a:ln>
+            <a:noFill/>
+          </a:ln>
+          <a:effectLst/>
+        </p:spPr>
+        <p:style>
+          <a:lnRef idx="1">
+            <a:schemeClr val="accent1"/>
+          </a:lnRef>
+          <a:fillRef idx="3">
+            <a:schemeClr val="accent1"/>
+          </a:fillRef>
+          <a:effectRef idx="2">
+            <a:schemeClr val="accent1"/>
+          </a:effectRef>
+          <a:fontRef idx="minor">
+            <a:schemeClr val="lt1"/>
+          </a:fontRef>
+        </p:style>
+        <p:txBody>
+          <a:bodyPr rtlCol="0" anchor="ctr"/>
+          <a:lstStyle/>
+          <a:p>
+            <a:pPr algn="ctr"/>
+          </a:p>
+        </p:txBody>
+      </p:sp>
+      <p:sp>
+        <p:nvSpPr>
+          <p:cNvPr id="8" name="TextBox 7"/>
+          <p:cNvSpPr txBox="1"/>
+          <p:nvPr/>
+        </p:nvSpPr>
+        <p:spPr>
+          <a:xfrm>
+            <a:off x="6720840" y="1874520"/>
+            <a:ext cx="4754880" cy="457200"/>
+          </a:xfrm>
+          <a:prstGeom prst="rect">
+            <a:avLst/>
+          </a:prstGeom>
+          <a:noFill/>
+        </p:spPr>
+        <p:txBody>
+          <a:bodyPr wrap="square">
+            <a:spAutoFit/>
+          </a:bodyPr>
+          <a:lstStyle/>
+          <a:p>
+            <a:r>
+              <a:rPr sz="1900" b="1">
+                <a:solidFill>
+                  <a:srgbClr val="0F766E"/>
+                </a:solidFill>
+                <a:latin typeface="Arial"/>
+              </a:rPr>
+              <a:t>Conclusiones</a:t>
+            </a:r>
+          </a:p>
+        </p:txBody>
+      </p:sp>
+      <p:sp>
+        <p:nvSpPr>
+          <p:cNvPr id="9" name="TextBox 8"/>
+          <p:cNvSpPr txBox="1"/>
+          <p:nvPr/>
+        </p:nvSpPr>
+        <p:spPr>
+          <a:xfrm>
+            <a:off x="6720840" y="2468880"/>
+            <a:ext cx="4754880" cy="3703320"/>
+          </a:xfrm>
+          <a:prstGeom prst="rect">
+            <a:avLst/>
+          </a:prstGeom>
+          <a:noFill/>
+        </p:spPr>
+        <p:txBody>
+          <a:bodyPr wrap="square">
+            <a:spAutoFit/>
+          </a:bodyPr>
+          <a:lstStyle/>
+          <a:p>
+            <a:pPr>
+              <a:spcAft>
+                <a:spcPts val="600"/>
+              </a:spcAft>
+            </a:pPr>
+            <a:r>
+              <a:rPr sz="1200">
+                <a:solidFill>
+                  <a:srgbClr val="1D2433"/>
+                </a:solidFill>
+                <a:latin typeface="Arial"/>
+              </a:rPr>
+              <a:t>Géneros diversos: top Drama, Documentary, Comedy; ninguno domina.</a:t>
+            </a:r>
+          </a:p>
+          <a:p>
+            <a:pPr>
+              <a:spcAft>
+                <a:spcPts val="600"/>
+              </a:spcAft>
+            </a:pPr>
+            <a:r>
+              <a:rPr sz="1200">
+                <a:solidFill>
+                  <a:srgbClr val="1D2433"/>
+                </a:solidFill>
+                <a:latin typeface="Arial"/>
+              </a:rPr>
+              <a:t>Faltantes estructurales dominados por finanzas (budget / revenue).</a:t>
+            </a:r>
+          </a:p>
+          <a:p>
+            <a:pPr>
+              <a:spcAft>
+                <a:spcPts val="600"/>
+              </a:spcAft>
+            </a:pPr>
+            <a:r>
+              <a:rPr sz="1200">
+                <a:solidFill>
+                  <a:srgbClr val="1D2433"/>
+                </a:solidFill>
+                <a:latin typeface="Arial"/>
+              </a:rPr>
+              <a:t>Preparación anti-leakage: split 80/20, imputación fit-en-train, log1p / capping de outliers.</a:t>
+            </a:r>
+          </a:p>
+          <a:p>
+            <a:pPr>
+              <a:spcAft>
+                <a:spcPts val="600"/>
+              </a:spcAft>
+            </a:pPr>
+            <a:r>
+              <a:rPr sz="1200">
+                <a:solidFill>
+                  <a:srgbClr val="1D2433"/>
+                </a:solidFill>
+                <a:latin typeface="Arial"/>
+              </a:rPr>
+              <a:t>185 registros con valores imposibles eliminados: finanzas fuera de rango o fechas erróneas (ver tabla).</a:t>
+            </a:r>
+          </a:p>
+          <a:p>
+            <a:pPr>
+              <a:spcAft>
+                <a:spcPts val="600"/>
+              </a:spcAft>
+            </a:pPr>
+            <a:r>
+              <a:rPr sz="1200">
+                <a:solidFill>
+                  <a:srgbClr val="1D2433"/>
+                </a:solidFill>
+                <a:latin typeface="Arial"/>
+              </a:rPr>
+              <a:t>Géneros codificados multi-hot (una película, varios géneros).</a:t>
             </a:r>
           </a:p>
         </p:txBody>

</xml_diff>

<commit_message>
add new analisis after class 5
</commit_message>
<xml_diff>
--- a/TP_Grupal_slides.pptx
+++ b/TP_Grupal_slides.pptx
@@ -6,9 +6,11 @@
   </p:sldMasterIdLst>
   <p:sldIdLst>
     <p:sldId id="256" r:id="rId7"/>
+    <p:sldId id="257" r:id="rId8"/>
     <p:sldId id="258" r:id="rId9"/>
-    <p:sldId id="257" r:id="rId8"/>
     <p:sldId id="259" r:id="rId10"/>
+    <p:sldId id="260" r:id="rId11"/>
+    <p:sldId id="261" r:id="rId12"/>
   </p:sldIdLst>
   <p:sldSz cx="12191695" cy="6858000" type="screen4x3"/>
   <p:notesSz cx="6858000" cy="9144000"/>
@@ -3179,7 +3181,7 @@
         <p:spPr>
           <a:xfrm>
             <a:off x="548640" y="1051560"/>
-            <a:ext cx="10972800" cy="457200"/>
+            <a:ext cx="11155680" cy="457200"/>
           </a:xfrm>
           <a:prstGeom prst="rect">
             <a:avLst/>
@@ -3200,7 +3202,7 @@
                 </a:solidFill>
                 <a:latin typeface="Arial"/>
               </a:rPr>
-              <a:t>Análisis exploratorio y preparación de datos (Clases 3–4) · EDA puro, sin variable target</a:t>
+              <a:t>Análisis exploratorio y preparación de datos (Clases 3–5) · popularity como target potencial de clasificación</a:t>
             </a:r>
           </a:p>
         </p:txBody>
@@ -3748,8 +3750,8 @@
         </p:nvSpPr>
         <p:spPr>
           <a:xfrm>
-            <a:off x="777240" y="3977639"/>
-            <a:ext cx="5029200" cy="2286000"/>
+            <a:off x="777240" y="4023360"/>
+            <a:ext cx="5029200" cy="2240280"/>
           </a:xfrm>
           <a:prstGeom prst="rect">
             <a:avLst/>
@@ -3762,13 +3764,25 @@
           </a:bodyPr>
           <a:lstStyle/>
           <a:p>
-            <a:pPr algn="l">
+            <a:pPr>
+              <a:lnSpc>
+                <a:spcPct val="110000"/>
+              </a:lnSpc>
               <a:spcAft>
-                <a:spcPts val="600"/>
+                <a:spcPts val="700"/>
               </a:spcAft>
             </a:pPr>
             <a:r>
-              <a:rPr sz="1300">
+              <a:rPr sz="1350" b="1">
+                <a:solidFill>
+                  <a:srgbClr val="0F766E"/>
+                </a:solidFill>
+                <a:latin typeface="Arial"/>
+              </a:rPr>
+              <a:t>•  </a:t>
+            </a:r>
+            <a:r>
+              <a:rPr sz="1350" b="0">
                 <a:solidFill>
                   <a:srgbClr val="1D2433"/>
                 </a:solidFill>
@@ -3779,66 +3793,150 @@
           </a:p>
           <a:p>
             <a:pPr>
+              <a:lnSpc>
+                <a:spcPct val="110000"/>
+              </a:lnSpc>
               <a:spcAft>
-                <a:spcPts val="600"/>
+                <a:spcPts val="700"/>
               </a:spcAft>
             </a:pPr>
             <a:r>
-              <a:rPr sz="1300">
-                <a:solidFill>
-                  <a:srgbClr val="1D2433"/>
-                </a:solidFill>
-                <a:latin typeface="Arial"/>
-              </a:rPr>
-              <a:t>Granularidad: 1 fila = 1 película, unidas por id.</a:t>
+              <a:rPr sz="1350" b="1">
+                <a:solidFill>
+                  <a:srgbClr val="0F766E"/>
+                </a:solidFill>
+                <a:latin typeface="Arial"/>
+              </a:rPr>
+              <a:t>•  </a:t>
+            </a:r>
+            <a:r>
+              <a:rPr sz="1350" b="1">
+                <a:solidFill>
+                  <a:srgbClr val="1D2433"/>
+                </a:solidFill>
+                <a:latin typeface="Arial"/>
+              </a:rPr>
+              <a:t>Granularidad:</a:t>
+            </a:r>
+            <a:r>
+              <a:rPr sz="1350" b="0">
+                <a:solidFill>
+                  <a:srgbClr val="1D2433"/>
+                </a:solidFill>
+                <a:latin typeface="Arial"/>
+              </a:rPr>
+              <a:t> 1 fila = 1 película, unidas por id.</a:t>
             </a:r>
           </a:p>
           <a:p>
             <a:pPr>
+              <a:lnSpc>
+                <a:spcPct val="110000"/>
+              </a:lnSpc>
               <a:spcAft>
-                <a:spcPts val="600"/>
+                <a:spcPts val="700"/>
               </a:spcAft>
             </a:pPr>
             <a:r>
-              <a:rPr sz="1300">
-                <a:solidFill>
-                  <a:srgbClr val="1D2433"/>
-                </a:solidFill>
-                <a:latin typeface="Arial"/>
-              </a:rPr>
-              <a:t>Numéricas: budget, revenue, runtime, votos, popularity.</a:t>
+              <a:rPr sz="1350" b="1">
+                <a:solidFill>
+                  <a:srgbClr val="0F766E"/>
+                </a:solidFill>
+                <a:latin typeface="Arial"/>
+              </a:rPr>
+              <a:t>•  </a:t>
+            </a:r>
+            <a:r>
+              <a:rPr sz="1350" b="1">
+                <a:solidFill>
+                  <a:srgbClr val="1D2433"/>
+                </a:solidFill>
+                <a:latin typeface="Arial"/>
+              </a:rPr>
+              <a:t>Numéricas:</a:t>
+            </a:r>
+            <a:r>
+              <a:rPr sz="1350" b="0">
+                <a:solidFill>
+                  <a:srgbClr val="1D2433"/>
+                </a:solidFill>
+                <a:latin typeface="Arial"/>
+              </a:rPr>
+              <a:t> budget, revenue, runtime, votos, popularity.</a:t>
             </a:r>
           </a:p>
           <a:p>
             <a:pPr>
+              <a:lnSpc>
+                <a:spcPct val="110000"/>
+              </a:lnSpc>
               <a:spcAft>
-                <a:spcPts val="600"/>
+                <a:spcPts val="700"/>
               </a:spcAft>
             </a:pPr>
             <a:r>
-              <a:rPr sz="1300">
-                <a:solidFill>
-                  <a:srgbClr val="1D2433"/>
-                </a:solidFill>
-                <a:latin typeface="Arial"/>
-              </a:rPr>
-              <a:t>Categóricas: género, idioma, estado.</a:t>
+              <a:rPr sz="1350" b="1">
+                <a:solidFill>
+                  <a:srgbClr val="0F766E"/>
+                </a:solidFill>
+                <a:latin typeface="Arial"/>
+              </a:rPr>
+              <a:t>•  </a:t>
+            </a:r>
+            <a:r>
+              <a:rPr sz="1350" b="1">
+                <a:solidFill>
+                  <a:srgbClr val="1D2433"/>
+                </a:solidFill>
+                <a:latin typeface="Arial"/>
+              </a:rPr>
+              <a:t>Categóricas:</a:t>
+            </a:r>
+            <a:r>
+              <a:rPr sz="1350" b="0">
+                <a:solidFill>
+                  <a:srgbClr val="1D2433"/>
+                </a:solidFill>
+                <a:latin typeface="Arial"/>
+              </a:rPr>
+              <a:t> género, idioma, estado.</a:t>
             </a:r>
           </a:p>
           <a:p>
             <a:pPr>
+              <a:lnSpc>
+                <a:spcPct val="110000"/>
+              </a:lnSpc>
               <a:spcAft>
-                <a:spcPts val="600"/>
+                <a:spcPts val="700"/>
               </a:spcAft>
             </a:pPr>
             <a:r>
-              <a:rPr sz="1300">
-                <a:solidFill>
-                  <a:srgbClr val="1D2433"/>
-                </a:solidFill>
-                <a:latin typeface="Arial"/>
-              </a:rPr>
-              <a:t>genres: multivariado, coma-separado (1-a-muchos).</a:t>
+              <a:rPr sz="1350" b="1">
+                <a:solidFill>
+                  <a:srgbClr val="0F766E"/>
+                </a:solidFill>
+                <a:latin typeface="Arial"/>
+              </a:rPr>
+              <a:t>•  </a:t>
+            </a:r>
+            <a:r>
+              <a:rPr sz="1350" b="1">
+                <a:solidFill>
+                  <a:srgbClr val="1D2433"/>
+                </a:solidFill>
+                <a:latin typeface="Arial"/>
+              </a:rPr>
+              <a:t>genres:</a:t>
+            </a:r>
+            <a:r>
+              <a:rPr sz="1350" b="0">
+                <a:solidFill>
+                  <a:srgbClr val="1D2433"/>
+                </a:solidFill>
+                <a:latin typeface="Arial"/>
+              </a:rPr>
+              <a:t> multivariado, coma-separado (1-a-muchos).</a:t>
             </a:r>
           </a:p>
         </p:txBody>
@@ -3930,8 +4028,8 @@
         </p:nvSpPr>
         <p:spPr>
           <a:xfrm>
-            <a:off x="6446520" y="3977639"/>
-            <a:ext cx="5029200" cy="2286000"/>
+            <a:off x="6446520" y="4023360"/>
+            <a:ext cx="5029200" cy="2240280"/>
           </a:xfrm>
           <a:prstGeom prst="rect">
             <a:avLst/>
@@ -3944,45 +4042,99 @@
           </a:bodyPr>
           <a:lstStyle/>
           <a:p>
-            <a:pPr algn="l">
+            <a:pPr>
+              <a:lnSpc>
+                <a:spcPct val="110000"/>
+              </a:lnSpc>
               <a:spcAft>
-                <a:spcPts val="600"/>
+                <a:spcPts val="700"/>
               </a:spcAft>
             </a:pPr>
             <a:r>
-              <a:rPr sz="1300">
-                <a:solidFill>
-                  <a:srgbClr val="1D2433"/>
-                </a:solidFill>
-                <a:latin typeface="Arial"/>
-              </a:rPr>
-              <a:t>Escala: 1,5 M de filas → cómputo vectorizado sobre el total.</a:t>
+              <a:rPr sz="1350" b="1">
+                <a:solidFill>
+                  <a:srgbClr val="D97706"/>
+                </a:solidFill>
+                <a:latin typeface="Arial"/>
+              </a:rPr>
+              <a:t>•  </a:t>
+            </a:r>
+            <a:r>
+              <a:rPr sz="1350" b="1">
+                <a:solidFill>
+                  <a:srgbClr val="1D2433"/>
+                </a:solidFill>
+                <a:latin typeface="Arial"/>
+              </a:rPr>
+              <a:t>Escala:</a:t>
+            </a:r>
+            <a:r>
+              <a:rPr sz="1350" b="0">
+                <a:solidFill>
+                  <a:srgbClr val="1D2433"/>
+                </a:solidFill>
+                <a:latin typeface="Arial"/>
+              </a:rPr>
+              <a:t> 1,5 M de filas → cómputo vectorizado sobre el total.</a:t>
             </a:r>
           </a:p>
           <a:p>
             <a:pPr>
+              <a:lnSpc>
+                <a:spcPct val="110000"/>
+              </a:lnSpc>
               <a:spcAft>
-                <a:spcPts val="600"/>
+                <a:spcPts val="700"/>
               </a:spcAft>
             </a:pPr>
             <a:r>
-              <a:rPr sz="1300">
-                <a:solidFill>
-                  <a:srgbClr val="1D2433"/>
-                </a:solidFill>
-                <a:latin typeface="Arial"/>
-              </a:rPr>
-              <a:t>Nulos masivos: revenue 98%, budget 94%.</a:t>
+              <a:rPr sz="1350" b="1">
+                <a:solidFill>
+                  <a:srgbClr val="D97706"/>
+                </a:solidFill>
+                <a:latin typeface="Arial"/>
+              </a:rPr>
+              <a:t>•  </a:t>
+            </a:r>
+            <a:r>
+              <a:rPr sz="1350" b="1">
+                <a:solidFill>
+                  <a:srgbClr val="1D2433"/>
+                </a:solidFill>
+                <a:latin typeface="Arial"/>
+              </a:rPr>
+              <a:t>Nulos masivos:</a:t>
+            </a:r>
+            <a:r>
+              <a:rPr sz="1350" b="0">
+                <a:solidFill>
+                  <a:srgbClr val="1D2433"/>
+                </a:solidFill>
+                <a:latin typeface="Arial"/>
+              </a:rPr>
+              <a:t> revenue 98%, budget 94%.</a:t>
             </a:r>
           </a:p>
           <a:p>
             <a:pPr>
+              <a:lnSpc>
+                <a:spcPct val="110000"/>
+              </a:lnSpc>
               <a:spcAft>
-                <a:spcPts val="600"/>
+                <a:spcPts val="700"/>
               </a:spcAft>
             </a:pPr>
             <a:r>
-              <a:rPr sz="1300">
+              <a:rPr sz="1350" b="1">
+                <a:solidFill>
+                  <a:srgbClr val="D97706"/>
+                </a:solidFill>
+                <a:latin typeface="Arial"/>
+              </a:rPr>
+              <a:t>•  </a:t>
+            </a:r>
+            <a:r>
+              <a:rPr sz="1350" b="0">
                 <a:solidFill>
                   <a:srgbClr val="1D2433"/>
                 </a:solidFill>
@@ -3993,18 +4145,39 @@
           </a:p>
           <a:p>
             <a:pPr>
+              <a:lnSpc>
+                <a:spcPct val="110000"/>
+              </a:lnSpc>
               <a:spcAft>
-                <a:spcPts val="600"/>
+                <a:spcPts val="700"/>
               </a:spcAft>
             </a:pPr>
             <a:r>
-              <a:rPr sz="1300">
-                <a:solidFill>
-                  <a:srgbClr val="1D2433"/>
-                </a:solidFill>
-                <a:latin typeface="Arial"/>
-              </a:rPr>
-              <a:t>Fuerte presencia de outliers: colas largas en budget, revenue, vote_count y popularity (asimetría extrema).</a:t>
+              <a:rPr sz="1350" b="1">
+                <a:solidFill>
+                  <a:srgbClr val="D97706"/>
+                </a:solidFill>
+                <a:latin typeface="Arial"/>
+              </a:rPr>
+              <a:t>•  </a:t>
+            </a:r>
+            <a:r>
+              <a:rPr sz="1350" b="1">
+                <a:solidFill>
+                  <a:srgbClr val="1D2433"/>
+                </a:solidFill>
+                <a:latin typeface="Arial"/>
+              </a:rPr>
+              <a:t>Fuerte presencia de outliers:</a:t>
+            </a:r>
+            <a:r>
+              <a:rPr sz="1350" b="0">
+                <a:solidFill>
+                  <a:srgbClr val="1D2433"/>
+                </a:solidFill>
+                <a:latin typeface="Arial"/>
+              </a:rPr>
+              <a:t> colas largas en budget, revenue, vote_count y popularity (asimetría extrema).</a:t>
             </a:r>
           </a:p>
         </p:txBody>
@@ -4042,7 +4215,7 @@
             <a:avLst/>
           </a:prstGeom>
           <a:solidFill>
-            <a:srgbClr val="7C3AED"/>
+            <a:srgbClr val="D97706"/>
           </a:solidFill>
           <a:ln>
             <a:noFill/>
@@ -4101,7 +4274,7 @@
                 </a:solidFill>
                 <a:latin typeface="Arial"/>
               </a:rPr>
-              <a:t>Calidad de datos: faltantes y su mecanismo</a:t>
+              <a:t>Asociaciones y pruebas de hipótesis</a:t>
             </a:r>
           </a:p>
         </p:txBody>
@@ -4136,38 +4309,62 @@
                 </a:solidFill>
                 <a:latin typeface="Arial"/>
               </a:rPr>
-              <a:t>Centinelas (0 / negativos) marcados como NaN antes de analizar</a:t>
+              <a:t>Asociación, no causalidad · Pearson (lineal) y Spearman (monótona) · α = 0.05</a:t>
             </a:r>
           </a:p>
         </p:txBody>
       </p:sp>
       <p:pic>
         <p:nvPicPr>
-          <p:cNvPr id="5" name="Picture 4" descr="nulos.png"/>
+          <p:cNvPr id="5" name="Picture 4" descr="corr.png"/>
           <p:cNvPicPr>
             <a:picLocks noChangeAspect="1"/>
           </p:cNvPicPr>
           <p:nvPr/>
         </p:nvPicPr>
         <p:blipFill>
-          <a:blip r:embed="rId6"/>
+          <a:blip r:embed="rId2"/>
           <a:stretch>
             <a:fillRect/>
           </a:stretch>
         </p:blipFill>
         <p:spPr>
           <a:xfrm>
-            <a:off x="548640" y="2459935"/>
-            <a:ext cx="5486400" cy="3126849"/>
+            <a:off x="457200" y="1600200"/>
+            <a:ext cx="5760720" cy="2391898"/>
           </a:xfrm>
           <a:prstGeom prst="rect">
             <a:avLst/>
           </a:prstGeom>
         </p:spPr>
       </p:pic>
-      <p:sp>
-        <p:nvSpPr>
-          <p:cNvPr id="6" name="Rounded Rectangle 5"/>
+      <p:pic>
+        <p:nvPicPr>
+          <p:cNvPr id="6" name="Picture 5" descr="tests.png"/>
+          <p:cNvPicPr>
+            <a:picLocks noChangeAspect="1"/>
+          </p:cNvPicPr>
+          <p:nvPr/>
+        </p:nvPicPr>
+        <p:blipFill>
+          <a:blip r:embed="rId3"/>
+          <a:stretch>
+            <a:fillRect/>
+          </a:stretch>
+        </p:blipFill>
+        <p:spPr>
+          <a:xfrm>
+            <a:off x="457200" y="4114800"/>
+            <a:ext cx="5760720" cy="1672155"/>
+          </a:xfrm>
+          <a:prstGeom prst="rect">
+            <a:avLst/>
+          </a:prstGeom>
+        </p:spPr>
+      </p:pic>
+      <p:sp>
+        <p:nvSpPr>
+          <p:cNvPr id="7" name="Rounded Rectangle 6"/>
           <p:cNvSpPr/>
           <p:nvPr/>
         </p:nvSpPr>
@@ -4211,48 +4408,14 @@
       </p:sp>
       <p:sp>
         <p:nvSpPr>
-          <p:cNvPr id="7" name="TextBox 6"/>
-          <p:cNvSpPr txBox="1"/>
-          <p:nvPr/>
-        </p:nvSpPr>
-        <p:spPr>
-          <a:xfrm>
-            <a:off x="6720840" y="1874520"/>
-            <a:ext cx="4754880" cy="457200"/>
-          </a:xfrm>
-          <a:prstGeom prst="rect">
-            <a:avLst/>
-          </a:prstGeom>
-          <a:noFill/>
-        </p:spPr>
-        <p:txBody>
-          <a:bodyPr wrap="square">
-            <a:spAutoFit/>
-          </a:bodyPr>
-          <a:lstStyle/>
-          <a:p>
-            <a:r>
-              <a:rPr sz="1900" b="1">
-                <a:solidFill>
-                  <a:srgbClr val="0F766E"/>
-                </a:solidFill>
-                <a:latin typeface="Arial"/>
-              </a:rPr>
-              <a:t>Mecanismos de faltantes</a:t>
-            </a:r>
-          </a:p>
-        </p:txBody>
-      </p:sp>
-      <p:sp>
-        <p:nvSpPr>
           <p:cNvPr id="8" name="TextBox 7"/>
           <p:cNvSpPr txBox="1"/>
           <p:nvPr/>
         </p:nvSpPr>
         <p:spPr>
           <a:xfrm>
-            <a:off x="6720840" y="2468880"/>
-            <a:ext cx="4754880" cy="3703320"/>
+            <a:off x="6720840" y="1874519"/>
+            <a:ext cx="4846320" cy="457200"/>
           </a:xfrm>
           <a:prstGeom prst="rect">
             <a:avLst/>
@@ -4260,88 +4423,210 @@
           <a:noFill/>
         </p:spPr>
         <p:txBody>
-          <a:bodyPr wrap="square">
+          <a:bodyPr wrap="square" anchor="t">
             <a:spAutoFit/>
           </a:bodyPr>
           <a:lstStyle/>
           <a:p>
+            <a:pPr algn="l"/>
+            <a:r>
+              <a:rPr sz="1900" b="1">
+                <a:solidFill>
+                  <a:srgbClr val="D97706"/>
+                </a:solidFill>
+                <a:latin typeface="Arial"/>
+              </a:rPr>
+              <a:t>Pruebas de hipótesis</a:t>
+            </a:r>
+          </a:p>
+        </p:txBody>
+      </p:sp>
+      <p:sp>
+        <p:nvSpPr>
+          <p:cNvPr id="9" name="TextBox 8"/>
+          <p:cNvSpPr txBox="1"/>
+          <p:nvPr/>
+        </p:nvSpPr>
+        <p:spPr>
+          <a:xfrm>
+            <a:off x="6720840" y="2514600"/>
+            <a:ext cx="4846320" cy="3657600"/>
+          </a:xfrm>
+          <a:prstGeom prst="rect">
+            <a:avLst/>
+          </a:prstGeom>
+          <a:noFill/>
+        </p:spPr>
+        <p:txBody>
+          <a:bodyPr wrap="square" anchor="t">
+            <a:spAutoFit/>
+          </a:bodyPr>
+          <a:lstStyle/>
+          <a:p>
             <a:pPr>
+              <a:lnSpc>
+                <a:spcPct val="110000"/>
+              </a:lnSpc>
               <a:spcAft>
-                <a:spcPts val="600"/>
+                <a:spcPts val="700"/>
               </a:spcAft>
             </a:pPr>
             <a:r>
-              <a:rPr sz="1250">
-                <a:solidFill>
-                  <a:srgbClr val="1D2433"/>
-                </a:solidFill>
-                <a:latin typeface="Arial"/>
-              </a:rPr>
-              <a:t>runtime ~32%: MCAR/MAR → imputable por mediana (fit en train).</a:t>
+              <a:rPr sz="1300" b="1">
+                <a:solidFill>
+                  <a:srgbClr val="D97706"/>
+                </a:solidFill>
+                <a:latin typeface="Arial"/>
+              </a:rPr>
+              <a:t>•  </a:t>
+            </a:r>
+            <a:r>
+              <a:rPr sz="1300" b="1">
+                <a:solidFill>
+                  <a:srgbClr val="1D2433"/>
+                </a:solidFill>
+                <a:latin typeface="Arial"/>
+              </a:rPr>
+              <a:t>H0:</a:t>
+            </a:r>
+            <a:r>
+              <a:rPr sz="1300" b="0">
+                <a:solidFill>
+                  <a:srgbClr val="1D2433"/>
+                </a:solidFill>
+                <a:latin typeface="Arial"/>
+              </a:rPr>
+              <a:t> r = 0 (sin asociación) · H1: r ≠ 0.</a:t>
             </a:r>
           </a:p>
           <a:p>
             <a:pPr>
+              <a:lnSpc>
+                <a:spcPct val="110000"/>
+              </a:lnSpc>
               <a:spcAft>
-                <a:spcPts val="600"/>
+                <a:spcPts val="700"/>
               </a:spcAft>
             </a:pPr>
             <a:r>
-              <a:rPr sz="1250">
-                <a:solidFill>
-                  <a:srgbClr val="1D2433"/>
-                </a:solidFill>
-                <a:latin typeface="Arial"/>
-              </a:rPr>
-              <a:t>budget 94% / revenue 98%: estructural → no se imputan; se agrega indicador tiene_budget / tiene_revenue.</a:t>
+              <a:rPr sz="1300" b="1">
+                <a:solidFill>
+                  <a:srgbClr val="D97706"/>
+                </a:solidFill>
+                <a:latin typeface="Arial"/>
+              </a:rPr>
+              <a:t>•  </a:t>
+            </a:r>
+            <a:r>
+              <a:rPr sz="1300" b="0">
+                <a:solidFill>
+                  <a:srgbClr val="1D2433"/>
+                </a:solidFill>
+                <a:latin typeface="Arial"/>
+              </a:rPr>
+              <a:t>Los 5 pares dan p &lt; 0.001 (≪ α): se rechaza H0 en todos → asociación estadísticamente significativa.</a:t>
             </a:r>
           </a:p>
           <a:p>
             <a:pPr>
+              <a:lnSpc>
+                <a:spcPct val="110000"/>
+              </a:lnSpc>
               <a:spcAft>
-                <a:spcPts val="600"/>
+                <a:spcPts val="700"/>
               </a:spcAft>
             </a:pPr>
             <a:r>
-              <a:rPr sz="1250">
-                <a:solidFill>
-                  <a:srgbClr val="1D2433"/>
-                </a:solidFill>
-                <a:latin typeface="Arial"/>
-              </a:rPr>
-              <a:t>vote_average 76%: falta exactamente cuando vote_count = 0 (estructural).</a:t>
+              <a:rPr sz="1300" b="1">
+                <a:solidFill>
+                  <a:srgbClr val="D97706"/>
+                </a:solidFill>
+                <a:latin typeface="Arial"/>
+              </a:rPr>
+              <a:t>•  </a:t>
+            </a:r>
+            <a:r>
+              <a:rPr sz="1300" b="1">
+                <a:solidFill>
+                  <a:srgbClr val="1D2433"/>
+                </a:solidFill>
+                <a:latin typeface="Arial"/>
+              </a:rPr>
+              <a:t>La más fuerte:</a:t>
+            </a:r>
+            <a:r>
+              <a:rPr sz="1300" b="0">
+                <a:solidFill>
+                  <a:srgbClr val="1D2433"/>
+                </a:solidFill>
+                <a:latin typeface="Arial"/>
+              </a:rPr>
+              <a:t> budget–revenue (Spearman 0.90, Pearson 0.56: la asimetría hace que Pearson la subestime).</a:t>
             </a:r>
           </a:p>
           <a:p>
             <a:pPr>
+              <a:lnSpc>
+                <a:spcPct val="110000"/>
+              </a:lnSpc>
               <a:spcAft>
-                <a:spcPts val="600"/>
+                <a:spcPts val="700"/>
               </a:spcAft>
             </a:pPr>
             <a:r>
-              <a:rPr sz="1250">
-                <a:solidFill>
-                  <a:srgbClr val="1D2433"/>
-                </a:solidFill>
-                <a:latin typeface="Arial"/>
-              </a:rPr>
-              <a:t>genres 45%: se marca con categoría propia 'SIN_GÉNERO'.</a:t>
+              <a:rPr sz="1300" b="1">
+                <a:solidFill>
+                  <a:srgbClr val="D97706"/>
+                </a:solidFill>
+                <a:latin typeface="Arial"/>
+              </a:rPr>
+              <a:t>•  </a:t>
+            </a:r>
+            <a:r>
+              <a:rPr sz="1300" b="1">
+                <a:solidFill>
+                  <a:srgbClr val="1D2433"/>
+                </a:solidFill>
+                <a:latin typeface="Arial"/>
+              </a:rPr>
+              <a:t>t-test género→vote_average:</a:t>
+            </a:r>
+            <a:r>
+              <a:rPr sz="1300" b="0">
+                <a:solidFill>
+                  <a:srgbClr val="1D2433"/>
+                </a:solidFill>
+                <a:latin typeface="Arial"/>
+              </a:rPr>
+              <a:t> p ≈ 0 → los documentales puntúan más alto (asociación, no causa).</a:t>
             </a:r>
           </a:p>
           <a:p>
             <a:pPr>
+              <a:lnSpc>
+                <a:spcPct val="110000"/>
+              </a:lnSpc>
               <a:spcAft>
-                <a:spcPts val="600"/>
+                <a:spcPts val="700"/>
               </a:spcAft>
             </a:pPr>
             <a:r>
-              <a:rPr sz="1250">
-                <a:solidFill>
-                  <a:srgbClr val="1D2433"/>
-                </a:solidFill>
-                <a:latin typeface="Arial"/>
-              </a:rPr>
-              <a:t>Regla &gt;70% nulos → no se imputa la columna.</a:t>
+              <a:rPr sz="1300" b="1">
+                <a:solidFill>
+                  <a:srgbClr val="D97706"/>
+                </a:solidFill>
+                <a:latin typeface="Arial"/>
+              </a:rPr>
+              <a:t>•  </a:t>
+            </a:r>
+            <a:r>
+              <a:rPr sz="1300" b="0">
+                <a:solidFill>
+                  <a:srgbClr val="1D2433"/>
+                </a:solidFill>
+                <a:latin typeface="Arial"/>
+              </a:rPr>
+              <a:t>Significación estadística ≠ causalidad.</a:t>
             </a:r>
           </a:p>
         </p:txBody>
@@ -4379,7 +4664,7 @@
             <a:avLst/>
           </a:prstGeom>
           <a:solidFill>
-            <a:srgbClr val="D97706"/>
+            <a:srgbClr val="7C3AED"/>
           </a:solidFill>
           <a:ln>
             <a:noFill/>
@@ -4438,7 +4723,7 @@
                 </a:solidFill>
                 <a:latin typeface="Arial"/>
               </a:rPr>
-              <a:t>Asociaciones y pruebas de hipótesis</a:t>
+              <a:t>Calidad de datos: faltantes y su mecanismo</a:t>
             </a:r>
           </a:p>
         </p:txBody>
@@ -4473,11 +4758,35 @@
                 </a:solidFill>
                 <a:latin typeface="Arial"/>
               </a:rPr>
-              <a:t>Asociación, no causalidad · Pearson (lineal) y Spearman (monótona) · α = 0.05</a:t>
-            </a:r>
-          </a:p>
-        </p:txBody>
-      </p:sp>
+              <a:t>Centinelas (0 / negativos) marcados como NaN antes de analizar</a:t>
+            </a:r>
+          </a:p>
+        </p:txBody>
+      </p:sp>
+      <p:pic>
+        <p:nvPicPr>
+          <p:cNvPr id="5" name="Picture 4" descr="nulos.png"/>
+          <p:cNvPicPr>
+            <a:picLocks noChangeAspect="1"/>
+          </p:cNvPicPr>
+          <p:nvPr/>
+        </p:nvPicPr>
+        <p:blipFill>
+          <a:blip r:embed="rId2"/>
+          <a:stretch>
+            <a:fillRect/>
+          </a:stretch>
+        </p:blipFill>
+        <p:spPr>
+          <a:xfrm>
+            <a:off x="548640" y="2459736"/>
+            <a:ext cx="5486400" cy="3126849"/>
+          </a:xfrm>
+          <a:prstGeom prst="rect">
+            <a:avLst/>
+          </a:prstGeom>
+        </p:spPr>
+      </p:pic>
       <p:sp>
         <p:nvSpPr>
           <p:cNvPr id="6" name="Rounded Rectangle 5"/>
@@ -4531,7 +4840,7 @@
         <p:spPr>
           <a:xfrm>
             <a:off x="6720840" y="1874519"/>
-            <a:ext cx="4846320" cy="457200"/>
+            <a:ext cx="4754880" cy="457200"/>
           </a:xfrm>
           <a:prstGeom prst="rect">
             <a:avLst/>
@@ -4548,11 +4857,11 @@
             <a:r>
               <a:rPr sz="1900" b="1">
                 <a:solidFill>
-                  <a:srgbClr val="D97706"/>
-                </a:solidFill>
-                <a:latin typeface="Arial"/>
-              </a:rPr>
-              <a:t>Pruebas de hipótesis</a:t>
+                  <a:srgbClr val="0F766E"/>
+                </a:solidFill>
+                <a:latin typeface="Arial"/>
+              </a:rPr>
+              <a:t>Mecanismos de faltantes</a:t>
             </a:r>
           </a:p>
         </p:txBody>
@@ -4565,8 +4874,8 @@
         </p:nvSpPr>
         <p:spPr>
           <a:xfrm>
-            <a:off x="6720840" y="2468880"/>
-            <a:ext cx="4846320" cy="3657600"/>
+            <a:off x="6720840" y="2514600"/>
+            <a:ext cx="4754880" cy="3703320"/>
           </a:xfrm>
           <a:prstGeom prst="rect">
             <a:avLst/>
@@ -4579,135 +4888,183 @@
           </a:bodyPr>
           <a:lstStyle/>
           <a:p>
-            <a:pPr algn="l">
+            <a:pPr>
+              <a:lnSpc>
+                <a:spcPct val="110000"/>
+              </a:lnSpc>
               <a:spcAft>
-                <a:spcPts val="600"/>
+                <a:spcPts val="700"/>
               </a:spcAft>
             </a:pPr>
             <a:r>
-              <a:rPr sz="1250">
-                <a:solidFill>
-                  <a:srgbClr val="1D2433"/>
-                </a:solidFill>
-                <a:latin typeface="Arial"/>
-              </a:rPr>
-              <a:t>H0: r = 0 (sin asociación) · H1: r ≠ 0.</a:t>
+              <a:rPr sz="1300" b="1">
+                <a:solidFill>
+                  <a:srgbClr val="0F766E"/>
+                </a:solidFill>
+                <a:latin typeface="Arial"/>
+              </a:rPr>
+              <a:t>•  </a:t>
+            </a:r>
+            <a:r>
+              <a:rPr sz="1300" b="1">
+                <a:solidFill>
+                  <a:srgbClr val="1D2433"/>
+                </a:solidFill>
+                <a:latin typeface="Arial"/>
+              </a:rPr>
+              <a:t>runtime ~32%:</a:t>
+            </a:r>
+            <a:r>
+              <a:rPr sz="1300" b="0">
+                <a:solidFill>
+                  <a:srgbClr val="1D2433"/>
+                </a:solidFill>
+                <a:latin typeface="Arial"/>
+              </a:rPr>
+              <a:t> MCAR/MAR → imputable por mediana (fit en train).</a:t>
             </a:r>
           </a:p>
           <a:p>
             <a:pPr>
+              <a:lnSpc>
+                <a:spcPct val="110000"/>
+              </a:lnSpc>
               <a:spcAft>
-                <a:spcPts val="600"/>
+                <a:spcPts val="700"/>
               </a:spcAft>
             </a:pPr>
             <a:r>
-              <a:rPr sz="1250">
-                <a:solidFill>
-                  <a:srgbClr val="1D2433"/>
-                </a:solidFill>
-                <a:latin typeface="Arial"/>
-              </a:rPr>
-              <a:t>Los 5 pares dan p &lt; 0.001 (≪ α): se rechaza H0 en todos → asociación estadísticamente significativa.</a:t>
+              <a:rPr sz="1300" b="1">
+                <a:solidFill>
+                  <a:srgbClr val="0F766E"/>
+                </a:solidFill>
+                <a:latin typeface="Arial"/>
+              </a:rPr>
+              <a:t>•  </a:t>
+            </a:r>
+            <a:r>
+              <a:rPr sz="1300" b="1">
+                <a:solidFill>
+                  <a:srgbClr val="1D2433"/>
+                </a:solidFill>
+                <a:latin typeface="Arial"/>
+              </a:rPr>
+              <a:t>budget 94% / revenue 98%:</a:t>
+            </a:r>
+            <a:r>
+              <a:rPr sz="1300" b="0">
+                <a:solidFill>
+                  <a:srgbClr val="1D2433"/>
+                </a:solidFill>
+                <a:latin typeface="Arial"/>
+              </a:rPr>
+              <a:t> estructural → no se imputan; se agrega indicador tiene_budget / tiene_revenue.</a:t>
             </a:r>
           </a:p>
           <a:p>
             <a:pPr>
+              <a:lnSpc>
+                <a:spcPct val="110000"/>
+              </a:lnSpc>
               <a:spcAft>
-                <a:spcPts val="600"/>
+                <a:spcPts val="700"/>
               </a:spcAft>
             </a:pPr>
             <a:r>
-              <a:rPr sz="1250">
-                <a:solidFill>
-                  <a:srgbClr val="1D2433"/>
-                </a:solidFill>
-                <a:latin typeface="Arial"/>
-              </a:rPr>
-              <a:t>La más fuerte: budget–revenue (Spearman 0.90, Pearson 0.56: la asimetría hace que Pearson la subestime).</a:t>
+              <a:rPr sz="1300" b="1">
+                <a:solidFill>
+                  <a:srgbClr val="0F766E"/>
+                </a:solidFill>
+                <a:latin typeface="Arial"/>
+              </a:rPr>
+              <a:t>•  </a:t>
+            </a:r>
+            <a:r>
+              <a:rPr sz="1300" b="1">
+                <a:solidFill>
+                  <a:srgbClr val="1D2433"/>
+                </a:solidFill>
+                <a:latin typeface="Arial"/>
+              </a:rPr>
+              <a:t>vote_average 76%:</a:t>
+            </a:r>
+            <a:r>
+              <a:rPr sz="1300" b="0">
+                <a:solidFill>
+                  <a:srgbClr val="1D2433"/>
+                </a:solidFill>
+                <a:latin typeface="Arial"/>
+              </a:rPr>
+              <a:t> falta exactamente cuando vote_count = 0 (estructural).</a:t>
             </a:r>
           </a:p>
           <a:p>
             <a:pPr>
+              <a:lnSpc>
+                <a:spcPct val="110000"/>
+              </a:lnSpc>
               <a:spcAft>
-                <a:spcPts val="600"/>
+                <a:spcPts val="700"/>
               </a:spcAft>
             </a:pPr>
             <a:r>
-              <a:rPr sz="1250">
-                <a:solidFill>
-                  <a:srgbClr val="1D2433"/>
-                </a:solidFill>
-                <a:latin typeface="Arial"/>
-              </a:rPr>
-              <a:t>t-test género→vote_average: p ≈ 0 → los documentales puntúan más alto (6.76 vs 6.06).</a:t>
+              <a:rPr sz="1300" b="1">
+                <a:solidFill>
+                  <a:srgbClr val="0F766E"/>
+                </a:solidFill>
+                <a:latin typeface="Arial"/>
+              </a:rPr>
+              <a:t>•  </a:t>
+            </a:r>
+            <a:r>
+              <a:rPr sz="1300" b="1">
+                <a:solidFill>
+                  <a:srgbClr val="1D2433"/>
+                </a:solidFill>
+                <a:latin typeface="Arial"/>
+              </a:rPr>
+              <a:t>genres 45%:</a:t>
+            </a:r>
+            <a:r>
+              <a:rPr sz="1300" b="0">
+                <a:solidFill>
+                  <a:srgbClr val="1D2433"/>
+                </a:solidFill>
+                <a:latin typeface="Arial"/>
+              </a:rPr>
+              <a:t> se marca con categoría propia 'SIN_GÉNERO'.</a:t>
             </a:r>
           </a:p>
           <a:p>
             <a:pPr>
+              <a:lnSpc>
+                <a:spcPct val="110000"/>
+              </a:lnSpc>
               <a:spcAft>
-                <a:spcPts val="600"/>
+                <a:spcPts val="700"/>
               </a:spcAft>
             </a:pPr>
             <a:r>
-              <a:rPr sz="1250">
-                <a:solidFill>
-                  <a:srgbClr val="1D2433"/>
-                </a:solidFill>
-                <a:latin typeface="Arial"/>
-              </a:rPr>
-              <a:t>Significación estadística ≠ causalidad.</a:t>
-            </a:r>
-          </a:p>
-        </p:txBody>
-      </p:sp>
-      <p:pic>
-        <p:nvPicPr>
-          <p:cNvPr id="9" name="Picture 8" descr="corr.png"/>
-          <p:cNvPicPr>
-            <a:picLocks noChangeAspect="1"/>
-          </p:cNvPicPr>
-          <p:nvPr/>
-        </p:nvPicPr>
-        <p:blipFill>
-          <a:blip r:embed="rId3"/>
-          <a:stretch>
-            <a:fillRect/>
-          </a:stretch>
-        </p:blipFill>
-        <p:spPr>
-          <a:xfrm>
-            <a:off x="457200" y="1600200"/>
-            <a:ext cx="5760720" cy="2391898"/>
-          </a:xfrm>
-          <a:prstGeom prst="rect">
-            <a:avLst/>
-          </a:prstGeom>
-        </p:spPr>
-      </p:pic>
-      <p:pic>
-        <p:nvPicPr>
-          <p:cNvPr id="10" name="Picture 9" descr="tests.png"/>
-          <p:cNvPicPr>
-            <a:picLocks noChangeAspect="1"/>
-          </p:cNvPicPr>
-          <p:nvPr/>
-        </p:nvPicPr>
-        <p:blipFill>
-          <a:blip r:embed="rId4"/>
-          <a:stretch>
-            <a:fillRect/>
-          </a:stretch>
-        </p:blipFill>
-        <p:spPr>
-          <a:xfrm>
-            <a:off x="457200" y="4114800"/>
-            <a:ext cx="5760720" cy="1672155"/>
-          </a:xfrm>
-          <a:prstGeom prst="rect">
-            <a:avLst/>
-          </a:prstGeom>
-        </p:spPr>
-      </p:pic>
+              <a:rPr sz="1300" b="1">
+                <a:solidFill>
+                  <a:srgbClr val="0F766E"/>
+                </a:solidFill>
+                <a:latin typeface="Arial"/>
+              </a:rPr>
+              <a:t>•  </a:t>
+            </a:r>
+            <a:r>
+              <a:rPr sz="1300" b="0">
+                <a:solidFill>
+                  <a:srgbClr val="1D2433"/>
+                </a:solidFill>
+                <a:latin typeface="Arial"/>
+              </a:rPr>
+              <a:t>Regla &gt;70% nulos → no se imputa la columna.</a:t>
+            </a:r>
+          </a:p>
+        </p:txBody>
+      </p:sp>
     </p:spTree>
   </p:cSld>
   <p:clrMapOvr>
@@ -4728,7 +5085,7 @@
       <p:grpSpPr/>
       <p:sp>
         <p:nvSpPr>
-          <p:cNvPr id="2" name="Rectangle 1"/>
+          <p:cNvPr id="2" name="Rounded Rectangle 1"/>
           <p:cNvSpPr/>
           <p:nvPr/>
         </p:nvSpPr>
@@ -4737,7 +5094,7 @@
             <a:off x="0" y="0"/>
             <a:ext cx="164592" cy="6858000"/>
           </a:xfrm>
-          <a:prstGeom prst="rect">
+          <a:prstGeom prst="roundRect">
             <a:avLst/>
           </a:prstGeom>
           <a:solidFill>
@@ -4787,11 +5144,12 @@
           <a:noFill/>
         </p:spPr>
         <p:txBody>
-          <a:bodyPr wrap="square">
+          <a:bodyPr wrap="square" anchor="t">
             <a:spAutoFit/>
           </a:bodyPr>
           <a:lstStyle/>
           <a:p>
+            <a:pPr algn="l"/>
             <a:r>
               <a:rPr sz="3400" b="1">
                 <a:solidFill>
@@ -4821,15 +5179,16 @@
           <a:noFill/>
         </p:spPr>
         <p:txBody>
-          <a:bodyPr wrap="square">
+          <a:bodyPr wrap="square" anchor="t">
             <a:spAutoFit/>
           </a:bodyPr>
           <a:lstStyle/>
           <a:p>
+            <a:pPr algn="l"/>
             <a:r>
               <a:rPr sz="1500" b="0">
                 <a:solidFill>
-                  <a:srgbClr val="475669"/>
+                  <a:srgbClr val="475569"/>
                 </a:solidFill>
                 <a:latin typeface="Arial"/>
               </a:rPr>
@@ -4938,7 +5297,7 @@
         </p:nvSpPr>
         <p:spPr>
           <a:xfrm>
-            <a:off x="6720840" y="1874520"/>
+            <a:off x="6720840" y="1874519"/>
             <a:ext cx="4754880" cy="457200"/>
           </a:xfrm>
           <a:prstGeom prst="rect">
@@ -4947,11 +5306,12 @@
           <a:noFill/>
         </p:spPr>
         <p:txBody>
-          <a:bodyPr wrap="square">
+          <a:bodyPr wrap="square" anchor="t">
             <a:spAutoFit/>
           </a:bodyPr>
           <a:lstStyle/>
           <a:p>
+            <a:pPr algn="l"/>
             <a:r>
               <a:rPr sz="1900" b="1">
                 <a:solidFill>
@@ -4972,7 +5332,7 @@
         </p:nvSpPr>
         <p:spPr>
           <a:xfrm>
-            <a:off x="6720840" y="2468880"/>
+            <a:off x="6720840" y="2514600"/>
             <a:ext cx="4754880" cy="3703320"/>
           </a:xfrm>
           <a:prstGeom prst="rect">
@@ -4981,34 +5341,67 @@
           <a:noFill/>
         </p:spPr>
         <p:txBody>
-          <a:bodyPr wrap="square">
+          <a:bodyPr wrap="square" anchor="t">
             <a:spAutoFit/>
           </a:bodyPr>
           <a:lstStyle/>
           <a:p>
             <a:pPr>
+              <a:lnSpc>
+                <a:spcPct val="110000"/>
+              </a:lnSpc>
               <a:spcAft>
-                <a:spcPts val="600"/>
+                <a:spcPts val="700"/>
               </a:spcAft>
             </a:pPr>
             <a:r>
-              <a:rPr sz="1200">
-                <a:solidFill>
-                  <a:srgbClr val="1D2433"/>
-                </a:solidFill>
-                <a:latin typeface="Arial"/>
-              </a:rPr>
-              <a:t>Géneros diversos: top Drama, Documentary, Comedy; ninguno domina.</a:t>
+              <a:rPr sz="1250" b="1">
+                <a:solidFill>
+                  <a:srgbClr val="0F766E"/>
+                </a:solidFill>
+                <a:latin typeface="Arial"/>
+              </a:rPr>
+              <a:t>•  </a:t>
+            </a:r>
+            <a:r>
+              <a:rPr sz="1250" b="1">
+                <a:solidFill>
+                  <a:srgbClr val="1D2433"/>
+                </a:solidFill>
+                <a:latin typeface="Arial"/>
+              </a:rPr>
+              <a:t>Géneros diversos:</a:t>
+            </a:r>
+            <a:r>
+              <a:rPr sz="1250" b="0">
+                <a:solidFill>
+                  <a:srgbClr val="1D2433"/>
+                </a:solidFill>
+                <a:latin typeface="Arial"/>
+              </a:rPr>
+              <a:t> top Drama, Documentary, Comedy; ninguno domina.</a:t>
             </a:r>
           </a:p>
           <a:p>
             <a:pPr>
+              <a:lnSpc>
+                <a:spcPct val="110000"/>
+              </a:lnSpc>
               <a:spcAft>
-                <a:spcPts val="600"/>
+                <a:spcPts val="700"/>
               </a:spcAft>
             </a:pPr>
             <a:r>
-              <a:rPr sz="1200">
+              <a:rPr sz="1250" b="1">
+                <a:solidFill>
+                  <a:srgbClr val="0F766E"/>
+                </a:solidFill>
+                <a:latin typeface="Arial"/>
+              </a:rPr>
+              <a:t>•  </a:t>
+            </a:r>
+            <a:r>
+              <a:rPr sz="1250" b="0">
                 <a:solidFill>
                   <a:srgbClr val="1D2433"/>
                 </a:solidFill>
@@ -5019,50 +5412,1769 @@
           </a:p>
           <a:p>
             <a:pPr>
+              <a:lnSpc>
+                <a:spcPct val="110000"/>
+              </a:lnSpc>
               <a:spcAft>
-                <a:spcPts val="600"/>
+                <a:spcPts val="700"/>
               </a:spcAft>
             </a:pPr>
             <a:r>
-              <a:rPr sz="1200">
-                <a:solidFill>
-                  <a:srgbClr val="1D2433"/>
-                </a:solidFill>
-                <a:latin typeface="Arial"/>
-              </a:rPr>
-              <a:t>Preparación anti-leakage: split 80/20, imputación fit-en-train, log1p / capping de outliers.</a:t>
+              <a:rPr sz="1250" b="1">
+                <a:solidFill>
+                  <a:srgbClr val="0F766E"/>
+                </a:solidFill>
+                <a:latin typeface="Arial"/>
+              </a:rPr>
+              <a:t>•  </a:t>
+            </a:r>
+            <a:r>
+              <a:rPr sz="1250" b="1">
+                <a:solidFill>
+                  <a:srgbClr val="1D2433"/>
+                </a:solidFill>
+                <a:latin typeface="Arial"/>
+              </a:rPr>
+              <a:t>Preparación anti-leakage:</a:t>
+            </a:r>
+            <a:r>
+              <a:rPr sz="1250" b="0">
+                <a:solidFill>
+                  <a:srgbClr val="1D2433"/>
+                </a:solidFill>
+                <a:latin typeface="Arial"/>
+              </a:rPr>
+              <a:t> split estratificado por popularity (target potencial), fit-en-train, log1p / capping.</a:t>
             </a:r>
           </a:p>
           <a:p>
             <a:pPr>
+              <a:lnSpc>
+                <a:spcPct val="110000"/>
+              </a:lnSpc>
               <a:spcAft>
-                <a:spcPts val="600"/>
+                <a:spcPts val="700"/>
               </a:spcAft>
             </a:pPr>
             <a:r>
-              <a:rPr sz="1200">
-                <a:solidFill>
-                  <a:srgbClr val="1D2433"/>
-                </a:solidFill>
-                <a:latin typeface="Arial"/>
-              </a:rPr>
-              <a:t>185 registros con valores imposibles eliminados: finanzas fuera de rango o fechas erróneas (ver tabla).</a:t>
+              <a:rPr sz="1250" b="1">
+                <a:solidFill>
+                  <a:srgbClr val="0F766E"/>
+                </a:solidFill>
+                <a:latin typeface="Arial"/>
+              </a:rPr>
+              <a:t>•  </a:t>
+            </a:r>
+            <a:r>
+              <a:rPr sz="1250" b="0">
+                <a:solidFill>
+                  <a:srgbClr val="1D2433"/>
+                </a:solidFill>
+                <a:latin typeface="Arial"/>
+              </a:rPr>
+              <a:t>185 registros con valores imposibles eliminados: finanzas fuera de rango o runtime imposible.</a:t>
             </a:r>
           </a:p>
           <a:p>
             <a:pPr>
+              <a:lnSpc>
+                <a:spcPct val="110000"/>
+              </a:lnSpc>
               <a:spcAft>
-                <a:spcPts val="600"/>
+                <a:spcPts val="700"/>
               </a:spcAft>
             </a:pPr>
             <a:r>
-              <a:rPr sz="1200">
+              <a:rPr sz="1250" b="1">
+                <a:solidFill>
+                  <a:srgbClr val="0F766E"/>
+                </a:solidFill>
+                <a:latin typeface="Arial"/>
+              </a:rPr>
+              <a:t>•  </a:t>
+            </a:r>
+            <a:r>
+              <a:rPr sz="1250" b="0">
                 <a:solidFill>
                   <a:srgbClr val="1D2433"/>
                 </a:solidFill>
                 <a:latin typeface="Arial"/>
               </a:rPr>
               <a:t>Géneros codificados multi-hot (una película, varios géneros).</a:t>
+            </a:r>
+          </a:p>
+        </p:txBody>
+      </p:sp>
+    </p:spTree>
+  </p:cSld>
+  <p:clrMapOvr>
+    <a:masterClrMapping/>
+  </p:clrMapOvr>
+</p:sld>
+</file>
+
+<file path=ppt/slides/slide5.xml><?xml version="1.0" encoding="utf-8"?>
+<p:sld xmlns:a="http://schemas.openxmlformats.org/drawingml/2006/main" xmlns:p="http://schemas.openxmlformats.org/presentationml/2006/main" xmlns:r="http://schemas.openxmlformats.org/officeDocument/2006/relationships">
+  <p:cSld>
+    <p:spTree>
+      <p:nvGrpSpPr>
+        <p:cNvPr id="1" name=""/>
+        <p:cNvGrpSpPr/>
+        <p:nvPr/>
+      </p:nvGrpSpPr>
+      <p:grpSpPr/>
+      <p:sp>
+        <p:nvSpPr>
+          <p:cNvPr id="2" name="Rounded Rectangle 1"/>
+          <p:cNvSpPr/>
+          <p:nvPr/>
+        </p:nvSpPr>
+        <p:spPr>
+          <a:xfrm>
+            <a:off x="0" y="0"/>
+            <a:ext cx="164592" cy="6858000"/>
+          </a:xfrm>
+          <a:prstGeom prst="roundRect">
+            <a:avLst/>
+          </a:prstGeom>
+          <a:solidFill>
+            <a:srgbClr val="7C3AED"/>
+          </a:solidFill>
+          <a:ln>
+            <a:noFill/>
+          </a:ln>
+          <a:effectLst/>
+        </p:spPr>
+        <p:style>
+          <a:lnRef idx="1">
+            <a:schemeClr val="accent1"/>
+          </a:lnRef>
+          <a:fillRef idx="3">
+            <a:schemeClr val="accent1"/>
+          </a:fillRef>
+          <a:effectRef idx="2">
+            <a:schemeClr val="accent1"/>
+          </a:effectRef>
+          <a:fontRef idx="minor">
+            <a:schemeClr val="lt1"/>
+          </a:fontRef>
+        </p:style>
+        <p:txBody>
+          <a:bodyPr rtlCol="0" anchor="ctr"/>
+          <a:lstStyle/>
+          <a:p>
+            <a:pPr algn="ctr"/>
+          </a:p>
+        </p:txBody>
+      </p:sp>
+      <p:sp>
+        <p:nvSpPr>
+          <p:cNvPr id="3" name="TextBox 2"/>
+          <p:cNvSpPr txBox="1"/>
+          <p:nvPr/>
+        </p:nvSpPr>
+        <p:spPr>
+          <a:xfrm>
+            <a:off x="502920" y="320040"/>
+            <a:ext cx="10972800" cy="731520"/>
+          </a:xfrm>
+          <a:prstGeom prst="rect">
+            <a:avLst/>
+          </a:prstGeom>
+          <a:noFill/>
+        </p:spPr>
+        <p:txBody>
+          <a:bodyPr wrap="square" anchor="t">
+            <a:spAutoFit/>
+          </a:bodyPr>
+          <a:lstStyle/>
+          <a:p>
+            <a:pPr algn="l"/>
+            <a:r>
+              <a:rPr sz="3400" b="1">
+                <a:solidFill>
+                  <a:srgbClr val="1D2433"/>
+                </a:solidFill>
+                <a:latin typeface="Arial"/>
+              </a:rPr>
+              <a:t>Preparación de datos: pipeline (Clases 4-5)</a:t>
+            </a:r>
+          </a:p>
+        </p:txBody>
+      </p:sp>
+      <p:sp>
+        <p:nvSpPr>
+          <p:cNvPr id="4" name="TextBox 3"/>
+          <p:cNvSpPr txBox="1"/>
+          <p:nvPr/>
+        </p:nvSpPr>
+        <p:spPr>
+          <a:xfrm>
+            <a:off x="548640" y="1051560"/>
+            <a:ext cx="11155680" cy="457200"/>
+          </a:xfrm>
+          <a:prstGeom prst="rect">
+            <a:avLst/>
+          </a:prstGeom>
+          <a:noFill/>
+        </p:spPr>
+        <p:txBody>
+          <a:bodyPr wrap="square" anchor="t">
+            <a:spAutoFit/>
+          </a:bodyPr>
+          <a:lstStyle/>
+          <a:p>
+            <a:pPr algn="l"/>
+            <a:r>
+              <a:rPr sz="1400" b="0">
+                <a:solidFill>
+                  <a:srgbClr val="475569"/>
+                </a:solidFill>
+                <a:latin typeface="Arial"/>
+              </a:rPr>
+              <a:t>popularity como target potencial · split estratificado · fit en train / transform en test</a:t>
+            </a:r>
+          </a:p>
+        </p:txBody>
+      </p:sp>
+      <p:sp>
+        <p:nvSpPr>
+          <p:cNvPr id="5" name="Rounded Rectangle 4"/>
+          <p:cNvSpPr/>
+          <p:nvPr/>
+        </p:nvSpPr>
+        <p:spPr>
+          <a:xfrm>
+            <a:off x="548640" y="1737360"/>
+            <a:ext cx="2560320" cy="1234440"/>
+          </a:xfrm>
+          <a:prstGeom prst="roundRect">
+            <a:avLst/>
+          </a:prstGeom>
+          <a:solidFill>
+            <a:srgbClr val="F1F5F9"/>
+          </a:solidFill>
+          <a:ln>
+            <a:noFill/>
+          </a:ln>
+          <a:effectLst/>
+        </p:spPr>
+        <p:style>
+          <a:lnRef idx="1">
+            <a:schemeClr val="accent1"/>
+          </a:lnRef>
+          <a:fillRef idx="3">
+            <a:schemeClr val="accent1"/>
+          </a:fillRef>
+          <a:effectRef idx="2">
+            <a:schemeClr val="accent1"/>
+          </a:effectRef>
+          <a:fontRef idx="minor">
+            <a:schemeClr val="lt1"/>
+          </a:fontRef>
+        </p:style>
+        <p:txBody>
+          <a:bodyPr rtlCol="0" anchor="ctr"/>
+          <a:lstStyle/>
+          <a:p>
+            <a:pPr algn="ctr"/>
+          </a:p>
+        </p:txBody>
+      </p:sp>
+      <p:sp>
+        <p:nvSpPr>
+          <p:cNvPr id="6" name="TextBox 5"/>
+          <p:cNvSpPr txBox="1"/>
+          <p:nvPr/>
+        </p:nvSpPr>
+        <p:spPr>
+          <a:xfrm>
+            <a:off x="731520" y="1828800"/>
+            <a:ext cx="2286000" cy="731520"/>
+          </a:xfrm>
+          <a:prstGeom prst="rect">
+            <a:avLst/>
+          </a:prstGeom>
+          <a:noFill/>
+        </p:spPr>
+        <p:txBody>
+          <a:bodyPr wrap="square" anchor="t">
+            <a:spAutoFit/>
+          </a:bodyPr>
+          <a:lstStyle/>
+          <a:p>
+            <a:pPr algn="l"/>
+            <a:r>
+              <a:rPr sz="2100" b="1">
+                <a:solidFill>
+                  <a:srgbClr val="0F766E"/>
+                </a:solidFill>
+                <a:latin typeface="Arial"/>
+              </a:rPr>
+              <a:t>1.199.797</a:t>
+            </a:r>
+          </a:p>
+        </p:txBody>
+      </p:sp>
+      <p:sp>
+        <p:nvSpPr>
+          <p:cNvPr id="7" name="TextBox 6"/>
+          <p:cNvSpPr txBox="1"/>
+          <p:nvPr/>
+        </p:nvSpPr>
+        <p:spPr>
+          <a:xfrm>
+            <a:off x="731520" y="2514600"/>
+            <a:ext cx="2286000" cy="457200"/>
+          </a:xfrm>
+          <a:prstGeom prst="rect">
+            <a:avLst/>
+          </a:prstGeom>
+          <a:noFill/>
+        </p:spPr>
+        <p:txBody>
+          <a:bodyPr wrap="square" anchor="t">
+            <a:spAutoFit/>
+          </a:bodyPr>
+          <a:lstStyle/>
+          <a:p>
+            <a:pPr algn="l"/>
+            <a:r>
+              <a:rPr sz="1500" b="0">
+                <a:solidFill>
+                  <a:srgbClr val="1D2433"/>
+                </a:solidFill>
+                <a:latin typeface="Arial"/>
+              </a:rPr>
+              <a:t>train</a:t>
+            </a:r>
+          </a:p>
+        </p:txBody>
+      </p:sp>
+      <p:sp>
+        <p:nvSpPr>
+          <p:cNvPr id="8" name="Rounded Rectangle 7"/>
+          <p:cNvSpPr/>
+          <p:nvPr/>
+        </p:nvSpPr>
+        <p:spPr>
+          <a:xfrm>
+            <a:off x="3337560" y="1737360"/>
+            <a:ext cx="2560320" cy="1234440"/>
+          </a:xfrm>
+          <a:prstGeom prst="roundRect">
+            <a:avLst/>
+          </a:prstGeom>
+          <a:solidFill>
+            <a:srgbClr val="F1F5F9"/>
+          </a:solidFill>
+          <a:ln>
+            <a:noFill/>
+          </a:ln>
+          <a:effectLst/>
+        </p:spPr>
+        <p:style>
+          <a:lnRef idx="1">
+            <a:schemeClr val="accent1"/>
+          </a:lnRef>
+          <a:fillRef idx="3">
+            <a:schemeClr val="accent1"/>
+          </a:fillRef>
+          <a:effectRef idx="2">
+            <a:schemeClr val="accent1"/>
+          </a:effectRef>
+          <a:fontRef idx="minor">
+            <a:schemeClr val="lt1"/>
+          </a:fontRef>
+        </p:style>
+        <p:txBody>
+          <a:bodyPr rtlCol="0" anchor="ctr"/>
+          <a:lstStyle/>
+          <a:p>
+            <a:pPr algn="ctr"/>
+          </a:p>
+        </p:txBody>
+      </p:sp>
+      <p:sp>
+        <p:nvSpPr>
+          <p:cNvPr id="9" name="TextBox 8"/>
+          <p:cNvSpPr txBox="1"/>
+          <p:nvPr/>
+        </p:nvSpPr>
+        <p:spPr>
+          <a:xfrm>
+            <a:off x="3520440" y="1828800"/>
+            <a:ext cx="2286000" cy="731520"/>
+          </a:xfrm>
+          <a:prstGeom prst="rect">
+            <a:avLst/>
+          </a:prstGeom>
+          <a:noFill/>
+        </p:spPr>
+        <p:txBody>
+          <a:bodyPr wrap="square" anchor="t">
+            <a:spAutoFit/>
+          </a:bodyPr>
+          <a:lstStyle/>
+          <a:p>
+            <a:pPr algn="l"/>
+            <a:r>
+              <a:rPr sz="2400" b="1">
+                <a:solidFill>
+                  <a:srgbClr val="7C3AED"/>
+                </a:solidFill>
+                <a:latin typeface="Arial"/>
+              </a:rPr>
+              <a:t>299.952</a:t>
+            </a:r>
+          </a:p>
+        </p:txBody>
+      </p:sp>
+      <p:sp>
+        <p:nvSpPr>
+          <p:cNvPr id="10" name="TextBox 9"/>
+          <p:cNvSpPr txBox="1"/>
+          <p:nvPr/>
+        </p:nvSpPr>
+        <p:spPr>
+          <a:xfrm>
+            <a:off x="3520440" y="2514600"/>
+            <a:ext cx="2286000" cy="457200"/>
+          </a:xfrm>
+          <a:prstGeom prst="rect">
+            <a:avLst/>
+          </a:prstGeom>
+          <a:noFill/>
+        </p:spPr>
+        <p:txBody>
+          <a:bodyPr wrap="square" anchor="t">
+            <a:spAutoFit/>
+          </a:bodyPr>
+          <a:lstStyle/>
+          <a:p>
+            <a:pPr algn="l"/>
+            <a:r>
+              <a:rPr sz="1500" b="0">
+                <a:solidFill>
+                  <a:srgbClr val="1D2433"/>
+                </a:solidFill>
+                <a:latin typeface="Arial"/>
+              </a:rPr>
+              <a:t>test</a:t>
+            </a:r>
+          </a:p>
+        </p:txBody>
+      </p:sp>
+      <p:sp>
+        <p:nvSpPr>
+          <p:cNvPr id="11" name="Rounded Rectangle 10"/>
+          <p:cNvSpPr/>
+          <p:nvPr/>
+        </p:nvSpPr>
+        <p:spPr>
+          <a:xfrm>
+            <a:off x="6126479" y="1737360"/>
+            <a:ext cx="2560320" cy="1234440"/>
+          </a:xfrm>
+          <a:prstGeom prst="roundRect">
+            <a:avLst/>
+          </a:prstGeom>
+          <a:solidFill>
+            <a:srgbClr val="F1F5F9"/>
+          </a:solidFill>
+          <a:ln>
+            <a:noFill/>
+          </a:ln>
+          <a:effectLst/>
+        </p:spPr>
+        <p:style>
+          <a:lnRef idx="1">
+            <a:schemeClr val="accent1"/>
+          </a:lnRef>
+          <a:fillRef idx="3">
+            <a:schemeClr val="accent1"/>
+          </a:fillRef>
+          <a:effectRef idx="2">
+            <a:schemeClr val="accent1"/>
+          </a:effectRef>
+          <a:fontRef idx="minor">
+            <a:schemeClr val="lt1"/>
+          </a:fontRef>
+        </p:style>
+        <p:txBody>
+          <a:bodyPr rtlCol="0" anchor="ctr"/>
+          <a:lstStyle/>
+          <a:p>
+            <a:pPr algn="ctr"/>
+          </a:p>
+        </p:txBody>
+      </p:sp>
+      <p:sp>
+        <p:nvSpPr>
+          <p:cNvPr id="12" name="TextBox 11"/>
+          <p:cNvSpPr txBox="1"/>
+          <p:nvPr/>
+        </p:nvSpPr>
+        <p:spPr>
+          <a:xfrm>
+            <a:off x="6309359" y="1828800"/>
+            <a:ext cx="2286000" cy="731520"/>
+          </a:xfrm>
+          <a:prstGeom prst="rect">
+            <a:avLst/>
+          </a:prstGeom>
+          <a:noFill/>
+        </p:spPr>
+        <p:txBody>
+          <a:bodyPr wrap="square" anchor="t">
+            <a:spAutoFit/>
+          </a:bodyPr>
+          <a:lstStyle/>
+          <a:p>
+            <a:pPr algn="l"/>
+            <a:r>
+              <a:rPr sz="3400" b="1">
+                <a:solidFill>
+                  <a:srgbClr val="D97706"/>
+                </a:solidFill>
+                <a:latin typeface="Arial"/>
+              </a:rPr>
+              <a:t>93</a:t>
+            </a:r>
+          </a:p>
+        </p:txBody>
+      </p:sp>
+      <p:sp>
+        <p:nvSpPr>
+          <p:cNvPr id="13" name="TextBox 12"/>
+          <p:cNvSpPr txBox="1"/>
+          <p:nvPr/>
+        </p:nvSpPr>
+        <p:spPr>
+          <a:xfrm>
+            <a:off x="6309359" y="2514600"/>
+            <a:ext cx="2286000" cy="457200"/>
+          </a:xfrm>
+          <a:prstGeom prst="rect">
+            <a:avLst/>
+          </a:prstGeom>
+          <a:noFill/>
+        </p:spPr>
+        <p:txBody>
+          <a:bodyPr wrap="square" anchor="t">
+            <a:spAutoFit/>
+          </a:bodyPr>
+          <a:lstStyle/>
+          <a:p>
+            <a:pPr algn="l"/>
+            <a:r>
+              <a:rPr sz="1500" b="0">
+                <a:solidFill>
+                  <a:srgbClr val="1D2433"/>
+                </a:solidFill>
+                <a:latin typeface="Arial"/>
+              </a:rPr>
+              <a:t>columnas finales</a:t>
+            </a:r>
+          </a:p>
+        </p:txBody>
+      </p:sp>
+      <p:sp>
+        <p:nvSpPr>
+          <p:cNvPr id="14" name="Rounded Rectangle 13"/>
+          <p:cNvSpPr/>
+          <p:nvPr/>
+        </p:nvSpPr>
+        <p:spPr>
+          <a:xfrm>
+            <a:off x="8915399" y="1737360"/>
+            <a:ext cx="2560320" cy="1234440"/>
+          </a:xfrm>
+          <a:prstGeom prst="roundRect">
+            <a:avLst/>
+          </a:prstGeom>
+          <a:solidFill>
+            <a:srgbClr val="F1F5F9"/>
+          </a:solidFill>
+          <a:ln>
+            <a:noFill/>
+          </a:ln>
+          <a:effectLst/>
+        </p:spPr>
+        <p:style>
+          <a:lnRef idx="1">
+            <a:schemeClr val="accent1"/>
+          </a:lnRef>
+          <a:fillRef idx="3">
+            <a:schemeClr val="accent1"/>
+          </a:fillRef>
+          <a:effectRef idx="2">
+            <a:schemeClr val="accent1"/>
+          </a:effectRef>
+          <a:fontRef idx="minor">
+            <a:schemeClr val="lt1"/>
+          </a:fontRef>
+        </p:style>
+        <p:txBody>
+          <a:bodyPr rtlCol="0" anchor="ctr"/>
+          <a:lstStyle/>
+          <a:p>
+            <a:pPr algn="ctr"/>
+          </a:p>
+        </p:txBody>
+      </p:sp>
+      <p:sp>
+        <p:nvSpPr>
+          <p:cNvPr id="15" name="TextBox 14"/>
+          <p:cNvSpPr txBox="1"/>
+          <p:nvPr/>
+        </p:nvSpPr>
+        <p:spPr>
+          <a:xfrm>
+            <a:off x="9098279" y="1828800"/>
+            <a:ext cx="2286000" cy="731520"/>
+          </a:xfrm>
+          <a:prstGeom prst="rect">
+            <a:avLst/>
+          </a:prstGeom>
+          <a:noFill/>
+        </p:spPr>
+        <p:txBody>
+          <a:bodyPr wrap="square" anchor="t">
+            <a:spAutoFit/>
+          </a:bodyPr>
+          <a:lstStyle/>
+          <a:p>
+            <a:pPr algn="l"/>
+            <a:r>
+              <a:rPr sz="3400" b="1">
+                <a:solidFill>
+                  <a:srgbClr val="475569"/>
+                </a:solidFill>
+                <a:latin typeface="Arial"/>
+              </a:rPr>
+              <a:t>3</a:t>
+            </a:r>
+          </a:p>
+        </p:txBody>
+      </p:sp>
+      <p:sp>
+        <p:nvSpPr>
+          <p:cNvPr id="16" name="TextBox 15"/>
+          <p:cNvSpPr txBox="1"/>
+          <p:nvPr/>
+        </p:nvSpPr>
+        <p:spPr>
+          <a:xfrm>
+            <a:off x="9098279" y="2514600"/>
+            <a:ext cx="2286000" cy="457200"/>
+          </a:xfrm>
+          <a:prstGeom prst="rect">
+            <a:avLst/>
+          </a:prstGeom>
+          <a:noFill/>
+        </p:spPr>
+        <p:txBody>
+          <a:bodyPr wrap="square" anchor="t">
+            <a:spAutoFit/>
+          </a:bodyPr>
+          <a:lstStyle/>
+          <a:p>
+            <a:pPr algn="l"/>
+            <a:r>
+              <a:rPr sz="1500" b="0">
+                <a:solidFill>
+                  <a:srgbClr val="1D2433"/>
+                </a:solidFill>
+                <a:latin typeface="Arial"/>
+              </a:rPr>
+              <a:t>clases target</a:t>
+            </a:r>
+          </a:p>
+        </p:txBody>
+      </p:sp>
+      <p:sp>
+        <p:nvSpPr>
+          <p:cNvPr id="17" name="Rounded Rectangle 16"/>
+          <p:cNvSpPr/>
+          <p:nvPr/>
+        </p:nvSpPr>
+        <p:spPr>
+          <a:xfrm>
+            <a:off x="548640" y="3291840"/>
+            <a:ext cx="5394960" cy="3108960"/>
+          </a:xfrm>
+          <a:prstGeom prst="roundRect">
+            <a:avLst/>
+          </a:prstGeom>
+          <a:solidFill>
+            <a:srgbClr val="F1F5F9"/>
+          </a:solidFill>
+          <a:ln>
+            <a:noFill/>
+          </a:ln>
+          <a:effectLst/>
+        </p:spPr>
+        <p:style>
+          <a:lnRef idx="1">
+            <a:schemeClr val="accent1"/>
+          </a:lnRef>
+          <a:fillRef idx="3">
+            <a:schemeClr val="accent1"/>
+          </a:fillRef>
+          <a:effectRef idx="2">
+            <a:schemeClr val="accent1"/>
+          </a:effectRef>
+          <a:fontRef idx="minor">
+            <a:schemeClr val="lt1"/>
+          </a:fontRef>
+        </p:style>
+        <p:txBody>
+          <a:bodyPr rtlCol="0" anchor="ctr"/>
+          <a:lstStyle/>
+          <a:p>
+            <a:pPr algn="ctr"/>
+          </a:p>
+        </p:txBody>
+      </p:sp>
+      <p:sp>
+        <p:nvSpPr>
+          <p:cNvPr id="18" name="TextBox 17"/>
+          <p:cNvSpPr txBox="1"/>
+          <p:nvPr/>
+        </p:nvSpPr>
+        <p:spPr>
+          <a:xfrm>
+            <a:off x="777240" y="3429000"/>
+            <a:ext cx="5029200" cy="457200"/>
+          </a:xfrm>
+          <a:prstGeom prst="rect">
+            <a:avLst/>
+          </a:prstGeom>
+          <a:noFill/>
+        </p:spPr>
+        <p:txBody>
+          <a:bodyPr wrap="square" anchor="t">
+            <a:spAutoFit/>
+          </a:bodyPr>
+          <a:lstStyle/>
+          <a:p>
+            <a:pPr algn="l"/>
+            <a:r>
+              <a:rPr sz="1900" b="1">
+                <a:solidFill>
+                  <a:srgbClr val="0F766E"/>
+                </a:solidFill>
+                <a:latin typeface="Arial"/>
+              </a:rPr>
+              <a:t>Pipeline</a:t>
+            </a:r>
+          </a:p>
+        </p:txBody>
+      </p:sp>
+      <p:sp>
+        <p:nvSpPr>
+          <p:cNvPr id="19" name="TextBox 18"/>
+          <p:cNvSpPr txBox="1"/>
+          <p:nvPr/>
+        </p:nvSpPr>
+        <p:spPr>
+          <a:xfrm>
+            <a:off x="777240" y="4023360"/>
+            <a:ext cx="5029200" cy="2240280"/>
+          </a:xfrm>
+          <a:prstGeom prst="rect">
+            <a:avLst/>
+          </a:prstGeom>
+          <a:noFill/>
+        </p:spPr>
+        <p:txBody>
+          <a:bodyPr wrap="square" anchor="t">
+            <a:spAutoFit/>
+          </a:bodyPr>
+          <a:lstStyle/>
+          <a:p>
+            <a:pPr>
+              <a:lnSpc>
+                <a:spcPct val="110000"/>
+              </a:lnSpc>
+              <a:spcAft>
+                <a:spcPts val="700"/>
+              </a:spcAft>
+            </a:pPr>
+            <a:r>
+              <a:rPr sz="1300" b="1">
+                <a:solidFill>
+                  <a:srgbClr val="0F766E"/>
+                </a:solidFill>
+                <a:latin typeface="Arial"/>
+              </a:rPr>
+              <a:t>•  </a:t>
+            </a:r>
+            <a:r>
+              <a:rPr sz="1300" b="0">
+                <a:solidFill>
+                  <a:srgbClr val="1D2433"/>
+                </a:solidFill>
+                <a:latin typeface="Arial"/>
+              </a:rPr>
+              <a:t>Split estratificado 80/20 por popularity_cat (baja &lt;1 · media 1-10 · alta ≥10; ~83/16/1%).</a:t>
+            </a:r>
+          </a:p>
+          <a:p>
+            <a:pPr>
+              <a:lnSpc>
+                <a:spcPct val="110000"/>
+              </a:lnSpc>
+              <a:spcAft>
+                <a:spcPts val="700"/>
+              </a:spcAft>
+            </a:pPr>
+            <a:r>
+              <a:rPr sz="1300" b="1">
+                <a:solidFill>
+                  <a:srgbClr val="0F766E"/>
+                </a:solidFill>
+                <a:latin typeface="Arial"/>
+              </a:rPr>
+              <a:t>•  </a:t>
+            </a:r>
+            <a:r>
+              <a:rPr sz="1300" b="1">
+                <a:solidFill>
+                  <a:srgbClr val="1D2433"/>
+                </a:solidFill>
+                <a:latin typeface="Arial"/>
+              </a:rPr>
+              <a:t>Imputación:</a:t>
+            </a:r>
+            <a:r>
+              <a:rPr sz="1300" b="0">
+                <a:solidFill>
+                  <a:srgbClr val="1D2433"/>
+                </a:solidFill>
+                <a:latin typeface="Arial"/>
+              </a:rPr>
+              <a:t> mediana fit-en-train (&gt;70% nulos → no se imputan, quedan tiene_*).</a:t>
+            </a:r>
+          </a:p>
+          <a:p>
+            <a:pPr>
+              <a:lnSpc>
+                <a:spcPct val="110000"/>
+              </a:lnSpc>
+              <a:spcAft>
+                <a:spcPts val="700"/>
+              </a:spcAft>
+            </a:pPr>
+            <a:r>
+              <a:rPr sz="1300" b="1">
+                <a:solidFill>
+                  <a:srgbClr val="0F766E"/>
+                </a:solidFill>
+                <a:latin typeface="Arial"/>
+              </a:rPr>
+              <a:t>•  </a:t>
+            </a:r>
+            <a:r>
+              <a:rPr sz="1300" b="1">
+                <a:solidFill>
+                  <a:srgbClr val="1D2433"/>
+                </a:solidFill>
+                <a:latin typeface="Arial"/>
+              </a:rPr>
+              <a:t>Outliers:</a:t>
+            </a:r>
+            <a:r>
+              <a:rPr sz="1300" b="0">
+                <a:solidFill>
+                  <a:srgbClr val="1D2433"/>
+                </a:solidFill>
+                <a:latin typeface="Arial"/>
+              </a:rPr>
+              <a:t> log1p (vote_count) + capping p1-p99 (runtime).</a:t>
+            </a:r>
+          </a:p>
+          <a:p>
+            <a:pPr>
+              <a:lnSpc>
+                <a:spcPct val="110000"/>
+              </a:lnSpc>
+              <a:spcAft>
+                <a:spcPts val="700"/>
+              </a:spcAft>
+            </a:pPr>
+            <a:r>
+              <a:rPr sz="1300" b="1">
+                <a:solidFill>
+                  <a:srgbClr val="0F766E"/>
+                </a:solidFill>
+                <a:latin typeface="Arial"/>
+              </a:rPr>
+              <a:t>•  </a:t>
+            </a:r>
+            <a:r>
+              <a:rPr sz="1300" b="1">
+                <a:solidFill>
+                  <a:srgbClr val="1D2433"/>
+                </a:solidFill>
+                <a:latin typeface="Arial"/>
+              </a:rPr>
+              <a:t>Discretización:</a:t>
+            </a:r>
+            <a:r>
+              <a:rPr sz="1300" b="0">
+                <a:solidFill>
+                  <a:srgbClr val="1D2433"/>
+                </a:solidFill>
+                <a:latin typeface="Arial"/>
+              </a:rPr>
+              <a:t> vote_average con qcut.</a:t>
+            </a:r>
+          </a:p>
+          <a:p>
+            <a:pPr>
+              <a:lnSpc>
+                <a:spcPct val="110000"/>
+              </a:lnSpc>
+              <a:spcAft>
+                <a:spcPts val="700"/>
+              </a:spcAft>
+            </a:pPr>
+            <a:r>
+              <a:rPr sz="1300" b="1">
+                <a:solidFill>
+                  <a:srgbClr val="0F766E"/>
+                </a:solidFill>
+                <a:latin typeface="Arial"/>
+              </a:rPr>
+              <a:t>•  </a:t>
+            </a:r>
+            <a:r>
+              <a:rPr sz="1300" b="0">
+                <a:solidFill>
+                  <a:srgbClr val="1D2433"/>
+                </a:solidFill>
+                <a:latin typeface="Arial"/>
+              </a:rPr>
+              <a:t>Escalado con Z-score (StandardScaler, fit en train) sobre las 11 numéricas continuas (runtime_cap, vote_count_log, anio, conteos n_* y largos len_*); binarias/OHE y target quedan fuera.</a:t>
+            </a:r>
+          </a:p>
+        </p:txBody>
+      </p:sp>
+      <p:sp>
+        <p:nvSpPr>
+          <p:cNvPr id="20" name="TextBox 19"/>
+          <p:cNvSpPr txBox="1"/>
+          <p:nvPr/>
+        </p:nvSpPr>
+        <p:spPr>
+          <a:xfrm>
+            <a:off x="6217920" y="3291840"/>
+            <a:ext cx="5394960" cy="457200"/>
+          </a:xfrm>
+          <a:prstGeom prst="rect">
+            <a:avLst/>
+          </a:prstGeom>
+          <a:noFill/>
+        </p:spPr>
+        <p:txBody>
+          <a:bodyPr wrap="square" anchor="t">
+            <a:spAutoFit/>
+          </a:bodyPr>
+          <a:lstStyle/>
+          <a:p>
+            <a:pPr algn="l"/>
+            <a:r>
+              <a:rPr sz="1500" b="1">
+                <a:solidFill>
+                  <a:srgbClr val="7C3AED"/>
+                </a:solidFill>
+                <a:latin typeface="Arial"/>
+              </a:rPr>
+              <a:t>Distribución del target (desbalance)</a:t>
+            </a:r>
+          </a:p>
+        </p:txBody>
+      </p:sp>
+      <p:pic>
+        <p:nvPicPr>
+          <p:cNvPr id="21" name="Picture 20" descr="target_balance.png"/>
+          <p:cNvPicPr>
+            <a:picLocks noChangeAspect="1"/>
+          </p:cNvPicPr>
+          <p:nvPr/>
+        </p:nvPicPr>
+        <p:blipFill>
+          <a:blip r:embed="rId2"/>
+          <a:stretch>
+            <a:fillRect/>
+          </a:stretch>
+        </p:blipFill>
+        <p:spPr>
+          <a:xfrm>
+            <a:off x="6309360" y="3703320"/>
+            <a:ext cx="5212080" cy="2657273"/>
+          </a:xfrm>
+          <a:prstGeom prst="rect">
+            <a:avLst/>
+          </a:prstGeom>
+        </p:spPr>
+      </p:pic>
+    </p:spTree>
+  </p:cSld>
+  <p:clrMapOvr>
+    <a:masterClrMapping/>
+  </p:clrMapOvr>
+</p:sld>
+</file>
+
+<file path=ppt/slides/slide6.xml><?xml version="1.0" encoding="utf-8"?>
+<p:sld xmlns:a="http://schemas.openxmlformats.org/drawingml/2006/main" xmlns:p="http://schemas.openxmlformats.org/presentationml/2006/main" xmlns:r="http://schemas.openxmlformats.org/officeDocument/2006/relationships">
+  <p:cSld>
+    <p:spTree>
+      <p:nvGrpSpPr>
+        <p:cNvPr id="1" name=""/>
+        <p:cNvGrpSpPr/>
+        <p:nvPr/>
+      </p:nvGrpSpPr>
+      <p:grpSpPr/>
+      <p:sp>
+        <p:nvSpPr>
+          <p:cNvPr id="2" name="Rounded Rectangle 1"/>
+          <p:cNvSpPr/>
+          <p:nvPr/>
+        </p:nvSpPr>
+        <p:spPr>
+          <a:xfrm>
+            <a:off x="0" y="0"/>
+            <a:ext cx="164592" cy="6858000"/>
+          </a:xfrm>
+          <a:prstGeom prst="roundRect">
+            <a:avLst/>
+          </a:prstGeom>
+          <a:solidFill>
+            <a:srgbClr val="D97706"/>
+          </a:solidFill>
+          <a:ln>
+            <a:noFill/>
+          </a:ln>
+          <a:effectLst/>
+        </p:spPr>
+        <p:style>
+          <a:lnRef idx="1">
+            <a:schemeClr val="accent1"/>
+          </a:lnRef>
+          <a:fillRef idx="3">
+            <a:schemeClr val="accent1"/>
+          </a:fillRef>
+          <a:effectRef idx="2">
+            <a:schemeClr val="accent1"/>
+          </a:effectRef>
+          <a:fontRef idx="minor">
+            <a:schemeClr val="lt1"/>
+          </a:fontRef>
+        </p:style>
+        <p:txBody>
+          <a:bodyPr rtlCol="0" anchor="ctr"/>
+          <a:lstStyle/>
+          <a:p>
+            <a:pPr algn="ctr"/>
+          </a:p>
+        </p:txBody>
+      </p:sp>
+      <p:sp>
+        <p:nvSpPr>
+          <p:cNvPr id="3" name="TextBox 2"/>
+          <p:cNvSpPr txBox="1"/>
+          <p:nvPr/>
+        </p:nvSpPr>
+        <p:spPr>
+          <a:xfrm>
+            <a:off x="502920" y="320040"/>
+            <a:ext cx="10972800" cy="731520"/>
+          </a:xfrm>
+          <a:prstGeom prst="rect">
+            <a:avLst/>
+          </a:prstGeom>
+          <a:noFill/>
+        </p:spPr>
+        <p:txBody>
+          <a:bodyPr wrap="square" anchor="t">
+            <a:spAutoFit/>
+          </a:bodyPr>
+          <a:lstStyle/>
+          <a:p>
+            <a:pPr algn="l"/>
+            <a:r>
+              <a:rPr sz="3400" b="1">
+                <a:solidFill>
+                  <a:srgbClr val="1D2433"/>
+                </a:solidFill>
+                <a:latin typeface="Arial"/>
+              </a:rPr>
+              <a:t>Codificación, features y dataset final</a:t>
+            </a:r>
+          </a:p>
+        </p:txBody>
+      </p:sp>
+      <p:sp>
+        <p:nvSpPr>
+          <p:cNvPr id="4" name="TextBox 3"/>
+          <p:cNvSpPr txBox="1"/>
+          <p:nvPr/>
+        </p:nvSpPr>
+        <p:spPr>
+          <a:xfrm>
+            <a:off x="548640" y="1051560"/>
+            <a:ext cx="11155680" cy="457200"/>
+          </a:xfrm>
+          <a:prstGeom prst="rect">
+            <a:avLst/>
+          </a:prstGeom>
+          <a:noFill/>
+        </p:spPr>
+        <p:txBody>
+          <a:bodyPr wrap="square" anchor="t">
+            <a:spAutoFit/>
+          </a:bodyPr>
+          <a:lstStyle/>
+          <a:p>
+            <a:pPr algn="l"/>
+            <a:r>
+              <a:rPr sz="1400" b="0">
+                <a:solidFill>
+                  <a:srgbClr val="475569"/>
+                </a:solidFill>
+                <a:latin typeface="Arial"/>
+              </a:rPr>
+              <a:t>de 24 columnas crudas a 93 features, con criterio anti-leakage</a:t>
+            </a:r>
+          </a:p>
+        </p:txBody>
+      </p:sp>
+      <p:sp>
+        <p:nvSpPr>
+          <p:cNvPr id="5" name="Rounded Rectangle 4"/>
+          <p:cNvSpPr/>
+          <p:nvPr/>
+        </p:nvSpPr>
+        <p:spPr>
+          <a:xfrm>
+            <a:off x="548640" y="1737360"/>
+            <a:ext cx="5394960" cy="4023360"/>
+          </a:xfrm>
+          <a:prstGeom prst="roundRect">
+            <a:avLst/>
+          </a:prstGeom>
+          <a:solidFill>
+            <a:srgbClr val="F1F5F9"/>
+          </a:solidFill>
+          <a:ln>
+            <a:noFill/>
+          </a:ln>
+          <a:effectLst/>
+        </p:spPr>
+        <p:style>
+          <a:lnRef idx="1">
+            <a:schemeClr val="accent1"/>
+          </a:lnRef>
+          <a:fillRef idx="3">
+            <a:schemeClr val="accent1"/>
+          </a:fillRef>
+          <a:effectRef idx="2">
+            <a:schemeClr val="accent1"/>
+          </a:effectRef>
+          <a:fontRef idx="minor">
+            <a:schemeClr val="lt1"/>
+          </a:fontRef>
+        </p:style>
+        <p:txBody>
+          <a:bodyPr rtlCol="0" anchor="ctr"/>
+          <a:lstStyle/>
+          <a:p>
+            <a:pPr algn="ctr"/>
+          </a:p>
+        </p:txBody>
+      </p:sp>
+      <p:sp>
+        <p:nvSpPr>
+          <p:cNvPr id="6" name="TextBox 5"/>
+          <p:cNvSpPr txBox="1"/>
+          <p:nvPr/>
+        </p:nvSpPr>
+        <p:spPr>
+          <a:xfrm>
+            <a:off x="777240" y="1874519"/>
+            <a:ext cx="5029200" cy="457200"/>
+          </a:xfrm>
+          <a:prstGeom prst="rect">
+            <a:avLst/>
+          </a:prstGeom>
+          <a:noFill/>
+        </p:spPr>
+        <p:txBody>
+          <a:bodyPr wrap="square" anchor="t">
+            <a:spAutoFit/>
+          </a:bodyPr>
+          <a:lstStyle/>
+          <a:p>
+            <a:pPr algn="l"/>
+            <a:r>
+              <a:rPr sz="1900" b="1">
+                <a:solidFill>
+                  <a:srgbClr val="0F766E"/>
+                </a:solidFill>
+                <a:latin typeface="Arial"/>
+              </a:rPr>
+              <a:t>Codificación</a:t>
+            </a:r>
+          </a:p>
+        </p:txBody>
+      </p:sp>
+      <p:sp>
+        <p:nvSpPr>
+          <p:cNvPr id="7" name="TextBox 6"/>
+          <p:cNvSpPr txBox="1"/>
+          <p:nvPr/>
+        </p:nvSpPr>
+        <p:spPr>
+          <a:xfrm>
+            <a:off x="777240" y="2514600"/>
+            <a:ext cx="5029200" cy="3108960"/>
+          </a:xfrm>
+          <a:prstGeom prst="rect">
+            <a:avLst/>
+          </a:prstGeom>
+          <a:noFill/>
+        </p:spPr>
+        <p:txBody>
+          <a:bodyPr wrap="square" anchor="t">
+            <a:spAutoFit/>
+          </a:bodyPr>
+          <a:lstStyle/>
+          <a:p>
+            <a:pPr>
+              <a:lnSpc>
+                <a:spcPct val="110000"/>
+              </a:lnSpc>
+              <a:spcAft>
+                <a:spcPts val="700"/>
+              </a:spcAft>
+            </a:pPr>
+            <a:r>
+              <a:rPr sz="1350" b="1">
+                <a:solidFill>
+                  <a:srgbClr val="0F766E"/>
+                </a:solidFill>
+                <a:latin typeface="Arial"/>
+              </a:rPr>
+              <a:t>•  </a:t>
+            </a:r>
+            <a:r>
+              <a:rPr sz="1350" b="1">
+                <a:solidFill>
+                  <a:srgbClr val="1D2433"/>
+                </a:solidFill>
+                <a:latin typeface="Arial"/>
+              </a:rPr>
+              <a:t>Géneros:</a:t>
+            </a:r>
+            <a:r>
+              <a:rPr sz="1350" b="0">
+                <a:solidFill>
+                  <a:srgbClr val="1D2433"/>
+                </a:solidFill>
+                <a:latin typeface="Arial"/>
+              </a:rPr>
+              <a:t> multi-hot (una película, varios géneros).</a:t>
+            </a:r>
+          </a:p>
+          <a:p>
+            <a:pPr>
+              <a:lnSpc>
+                <a:spcPct val="110000"/>
+              </a:lnSpc>
+              <a:spcAft>
+                <a:spcPts val="700"/>
+              </a:spcAft>
+            </a:pPr>
+            <a:r>
+              <a:rPr sz="1350" b="1">
+                <a:solidFill>
+                  <a:srgbClr val="0F766E"/>
+                </a:solidFill>
+                <a:latin typeface="Arial"/>
+              </a:rPr>
+              <a:t>•  </a:t>
+            </a:r>
+            <a:r>
+              <a:rPr sz="1350" b="1">
+                <a:solidFill>
+                  <a:srgbClr val="1D2433"/>
+                </a:solidFill>
+                <a:latin typeface="Arial"/>
+              </a:rPr>
+              <a:t>status:</a:t>
+            </a:r>
+            <a:r>
+              <a:rPr sz="1350" b="0">
+                <a:solidFill>
+                  <a:srgbClr val="1D2433"/>
+                </a:solidFill>
+                <a:latin typeface="Arial"/>
+              </a:rPr>
+              <a:t> OHE 3 vías (Released / In Production / otros).</a:t>
+            </a:r>
+          </a:p>
+          <a:p>
+            <a:pPr>
+              <a:lnSpc>
+                <a:spcPct val="110000"/>
+              </a:lnSpc>
+              <a:spcAft>
+                <a:spcPts val="700"/>
+              </a:spcAft>
+            </a:pPr>
+            <a:r>
+              <a:rPr sz="1350" b="1">
+                <a:solidFill>
+                  <a:srgbClr val="0F766E"/>
+                </a:solidFill>
+                <a:latin typeface="Arial"/>
+              </a:rPr>
+              <a:t>•  </a:t>
+            </a:r>
+            <a:r>
+              <a:rPr sz="1350" b="1">
+                <a:solidFill>
+                  <a:srgbClr val="1D2433"/>
+                </a:solidFill>
+                <a:latin typeface="Arial"/>
+              </a:rPr>
+              <a:t>adult:</a:t>
+            </a:r>
+            <a:r>
+              <a:rPr sz="1350" b="0">
+                <a:solidFill>
+                  <a:srgbClr val="1D2433"/>
+                </a:solidFill>
+                <a:latin typeface="Arial"/>
+              </a:rPr>
+              <a:t> a entero (0/1).</a:t>
+            </a:r>
+          </a:p>
+          <a:p>
+            <a:pPr>
+              <a:lnSpc>
+                <a:spcPct val="110000"/>
+              </a:lnSpc>
+              <a:spcAft>
+                <a:spcPts val="700"/>
+              </a:spcAft>
+            </a:pPr>
+            <a:r>
+              <a:rPr sz="1350" b="1">
+                <a:solidFill>
+                  <a:srgbClr val="0F766E"/>
+                </a:solidFill>
+                <a:latin typeface="Arial"/>
+              </a:rPr>
+              <a:t>•  </a:t>
+            </a:r>
+            <a:r>
+              <a:rPr sz="1350" b="1">
+                <a:solidFill>
+                  <a:srgbClr val="1D2433"/>
+                </a:solidFill>
+                <a:latin typeface="Arial"/>
+              </a:rPr>
+              <a:t>original_language:</a:t>
+            </a:r>
+            <a:r>
+              <a:rPr sz="1350" b="0">
+                <a:solidFill>
+                  <a:srgbClr val="1D2433"/>
+                </a:solidFill>
+                <a:latin typeface="Arial"/>
+              </a:rPr>
+              <a:t> OHE top-10 + 'otros'.</a:t>
+            </a:r>
+          </a:p>
+          <a:p>
+            <a:pPr>
+              <a:lnSpc>
+                <a:spcPct val="110000"/>
+              </a:lnSpc>
+              <a:spcAft>
+                <a:spcPts val="700"/>
+              </a:spcAft>
+            </a:pPr>
+            <a:r>
+              <a:rPr sz="1350" b="1">
+                <a:solidFill>
+                  <a:srgbClr val="0F766E"/>
+                </a:solidFill>
+                <a:latin typeface="Arial"/>
+              </a:rPr>
+              <a:t>•  </a:t>
+            </a:r>
+            <a:r>
+              <a:rPr sz="1350" b="0">
+                <a:solidFill>
+                  <a:srgbClr val="1D2433"/>
+                </a:solidFill>
+                <a:latin typeface="Arial"/>
+              </a:rPr>
+              <a:t>spoken_languages / production_countries / production_companies: multi-hot top-15 + 'otros'.</a:t>
+            </a:r>
+          </a:p>
+        </p:txBody>
+      </p:sp>
+      <p:sp>
+        <p:nvSpPr>
+          <p:cNvPr id="8" name="Rounded Rectangle 7"/>
+          <p:cNvSpPr/>
+          <p:nvPr/>
+        </p:nvSpPr>
+        <p:spPr>
+          <a:xfrm>
+            <a:off x="6217920" y="1737360"/>
+            <a:ext cx="5394960" cy="4023360"/>
+          </a:xfrm>
+          <a:prstGeom prst="roundRect">
+            <a:avLst/>
+          </a:prstGeom>
+          <a:solidFill>
+            <a:srgbClr val="FDF2E9"/>
+          </a:solidFill>
+          <a:ln>
+            <a:noFill/>
+          </a:ln>
+          <a:effectLst/>
+        </p:spPr>
+        <p:style>
+          <a:lnRef idx="1">
+            <a:schemeClr val="accent1"/>
+          </a:lnRef>
+          <a:fillRef idx="3">
+            <a:schemeClr val="accent1"/>
+          </a:fillRef>
+          <a:effectRef idx="2">
+            <a:schemeClr val="accent1"/>
+          </a:effectRef>
+          <a:fontRef idx="minor">
+            <a:schemeClr val="lt1"/>
+          </a:fontRef>
+        </p:style>
+        <p:txBody>
+          <a:bodyPr rtlCol="0" anchor="ctr"/>
+          <a:lstStyle/>
+          <a:p>
+            <a:pPr algn="ctr"/>
+          </a:p>
+        </p:txBody>
+      </p:sp>
+      <p:sp>
+        <p:nvSpPr>
+          <p:cNvPr id="9" name="TextBox 8"/>
+          <p:cNvSpPr txBox="1"/>
+          <p:nvPr/>
+        </p:nvSpPr>
+        <p:spPr>
+          <a:xfrm>
+            <a:off x="6446520" y="1874519"/>
+            <a:ext cx="5029200" cy="457200"/>
+          </a:xfrm>
+          <a:prstGeom prst="rect">
+            <a:avLst/>
+          </a:prstGeom>
+          <a:noFill/>
+        </p:spPr>
+        <p:txBody>
+          <a:bodyPr wrap="square" anchor="t">
+            <a:spAutoFit/>
+          </a:bodyPr>
+          <a:lstStyle/>
+          <a:p>
+            <a:pPr algn="l"/>
+            <a:r>
+              <a:rPr sz="1900" b="1">
+                <a:solidFill>
+                  <a:srgbClr val="D97706"/>
+                </a:solidFill>
+                <a:latin typeface="Arial"/>
+              </a:rPr>
+              <a:t>Features e indicadores</a:t>
+            </a:r>
+          </a:p>
+        </p:txBody>
+      </p:sp>
+      <p:sp>
+        <p:nvSpPr>
+          <p:cNvPr id="10" name="TextBox 9"/>
+          <p:cNvSpPr txBox="1"/>
+          <p:nvPr/>
+        </p:nvSpPr>
+        <p:spPr>
+          <a:xfrm>
+            <a:off x="6446520" y="2514600"/>
+            <a:ext cx="5029200" cy="3108960"/>
+          </a:xfrm>
+          <a:prstGeom prst="rect">
+            <a:avLst/>
+          </a:prstGeom>
+          <a:noFill/>
+        </p:spPr>
+        <p:txBody>
+          <a:bodyPr wrap="square" anchor="t">
+            <a:spAutoFit/>
+          </a:bodyPr>
+          <a:lstStyle/>
+          <a:p>
+            <a:pPr>
+              <a:lnSpc>
+                <a:spcPct val="110000"/>
+              </a:lnSpc>
+              <a:spcAft>
+                <a:spcPts val="700"/>
+              </a:spcAft>
+            </a:pPr>
+            <a:r>
+              <a:rPr sz="1350" b="1">
+                <a:solidFill>
+                  <a:srgbClr val="D97706"/>
+                </a:solidFill>
+                <a:latin typeface="Arial"/>
+              </a:rPr>
+              <a:t>•  </a:t>
+            </a:r>
+            <a:r>
+              <a:rPr sz="1350" b="0">
+                <a:solidFill>
+                  <a:srgbClr val="1D2433"/>
+                </a:solidFill>
+                <a:latin typeface="Arial"/>
+              </a:rPr>
+              <a:t>Indicadores tiene_* (URLs, texto libre, finanzas).</a:t>
+            </a:r>
+          </a:p>
+          <a:p>
+            <a:pPr>
+              <a:lnSpc>
+                <a:spcPct val="110000"/>
+              </a:lnSpc>
+              <a:spcAft>
+                <a:spcPts val="700"/>
+              </a:spcAft>
+            </a:pPr>
+            <a:r>
+              <a:rPr sz="1350" b="1">
+                <a:solidFill>
+                  <a:srgbClr val="D97706"/>
+                </a:solidFill>
+                <a:latin typeface="Arial"/>
+              </a:rPr>
+              <a:t>•  </a:t>
+            </a:r>
+            <a:r>
+              <a:rPr sz="1350" b="0">
+                <a:solidFill>
+                  <a:srgbClr val="1D2433"/>
+                </a:solidFill>
+                <a:latin typeface="Arial"/>
+              </a:rPr>
+              <a:t>Conteos n_* (géneros, idiomas, países, compañías, keywords).</a:t>
+            </a:r>
+          </a:p>
+          <a:p>
+            <a:pPr>
+              <a:lnSpc>
+                <a:spcPct val="110000"/>
+              </a:lnSpc>
+              <a:spcAft>
+                <a:spcPts val="700"/>
+              </a:spcAft>
+            </a:pPr>
+            <a:r>
+              <a:rPr sz="1350" b="1">
+                <a:solidFill>
+                  <a:srgbClr val="D97706"/>
+                </a:solidFill>
+                <a:latin typeface="Arial"/>
+              </a:rPr>
+              <a:t>•  </a:t>
+            </a:r>
+            <a:r>
+              <a:rPr sz="1350" b="1">
+                <a:solidFill>
+                  <a:srgbClr val="1D2433"/>
+                </a:solidFill>
+                <a:latin typeface="Arial"/>
+              </a:rPr>
+              <a:t>Largos:</a:t>
+            </a:r>
+            <a:r>
+              <a:rPr sz="1350" b="0">
+                <a:solidFill>
+                  <a:srgbClr val="1D2433"/>
+                </a:solidFill>
+                <a:latin typeface="Arial"/>
+              </a:rPr>
+              <a:t> title_length, len_overview, len_tagline.</a:t>
+            </a:r>
+          </a:p>
+          <a:p>
+            <a:pPr>
+              <a:lnSpc>
+                <a:spcPct val="110000"/>
+              </a:lnSpc>
+              <a:spcAft>
+                <a:spcPts val="700"/>
+              </a:spcAft>
+            </a:pPr>
+            <a:r>
+              <a:rPr sz="1350" b="1">
+                <a:solidFill>
+                  <a:srgbClr val="D97706"/>
+                </a:solidFill>
+                <a:latin typeface="Arial"/>
+              </a:rPr>
+              <a:t>•  </a:t>
+            </a:r>
+            <a:r>
+              <a:rPr sz="1350" b="1">
+                <a:solidFill>
+                  <a:srgbClr val="1D2433"/>
+                </a:solidFill>
+                <a:latin typeface="Arial"/>
+              </a:rPr>
+              <a:t>Temporales:</a:t>
+            </a:r>
+            <a:r>
+              <a:rPr sz="1350" b="0">
+                <a:solidFill>
+                  <a:srgbClr val="1D2433"/>
+                </a:solidFill>
+                <a:latin typeface="Arial"/>
+              </a:rPr>
+              <a:t> anio, decada, mes.</a:t>
+            </a:r>
+          </a:p>
+          <a:p>
+            <a:pPr>
+              <a:lnSpc>
+                <a:spcPct val="110000"/>
+              </a:lnSpc>
+              <a:spcAft>
+                <a:spcPts val="700"/>
+              </a:spcAft>
+            </a:pPr>
+            <a:r>
+              <a:rPr sz="1350" b="1">
+                <a:solidFill>
+                  <a:srgbClr val="D97706"/>
+                </a:solidFill>
+                <a:latin typeface="Arial"/>
+              </a:rPr>
+              <a:t>•  </a:t>
+            </a:r>
+            <a:r>
+              <a:rPr sz="1350" b="1">
+                <a:solidFill>
+                  <a:srgbClr val="1D2433"/>
+                </a:solidFill>
+                <a:latin typeface="Arial"/>
+              </a:rPr>
+              <a:t>Anti-leakage:</a:t>
+            </a:r>
+            <a:r>
+              <a:rPr sz="1350" b="0">
+                <a:solidFill>
+                  <a:srgbClr val="1D2433"/>
+                </a:solidFill>
+                <a:latin typeface="Arial"/>
+              </a:rPr>
+              <a:t> rankings top-N aprendidos solo en train; categorías no vistas en test → 'otros'.</a:t>
+            </a:r>
+          </a:p>
+        </p:txBody>
+      </p:sp>
+      <p:sp>
+        <p:nvSpPr>
+          <p:cNvPr id="11" name="Rounded Rectangle 10"/>
+          <p:cNvSpPr/>
+          <p:nvPr/>
+        </p:nvSpPr>
+        <p:spPr>
+          <a:xfrm>
+            <a:off x="548640" y="5943600"/>
+            <a:ext cx="11064240" cy="685800"/>
+          </a:xfrm>
+          <a:prstGeom prst="roundRect">
+            <a:avLst/>
+          </a:prstGeom>
+          <a:solidFill>
+            <a:srgbClr val="F1F5F9"/>
+          </a:solidFill>
+          <a:ln>
+            <a:noFill/>
+          </a:ln>
+          <a:effectLst/>
+        </p:spPr>
+        <p:style>
+          <a:lnRef idx="1">
+            <a:schemeClr val="accent1"/>
+          </a:lnRef>
+          <a:fillRef idx="3">
+            <a:schemeClr val="accent1"/>
+          </a:fillRef>
+          <a:effectRef idx="2">
+            <a:schemeClr val="accent1"/>
+          </a:effectRef>
+          <a:fontRef idx="minor">
+            <a:schemeClr val="lt1"/>
+          </a:fontRef>
+        </p:style>
+        <p:txBody>
+          <a:bodyPr rtlCol="0" anchor="ctr"/>
+          <a:lstStyle/>
+          <a:p>
+            <a:pPr algn="ctr"/>
+          </a:p>
+        </p:txBody>
+      </p:sp>
+      <p:sp>
+        <p:nvSpPr>
+          <p:cNvPr id="12" name="TextBox 11"/>
+          <p:cNvSpPr txBox="1"/>
+          <p:nvPr/>
+        </p:nvSpPr>
+        <p:spPr>
+          <a:xfrm>
+            <a:off x="548640" y="6053328"/>
+            <a:ext cx="11064240" cy="457200"/>
+          </a:xfrm>
+          <a:prstGeom prst="rect">
+            <a:avLst/>
+          </a:prstGeom>
+          <a:noFill/>
+        </p:spPr>
+        <p:txBody>
+          <a:bodyPr wrap="square" anchor="t">
+            <a:spAutoFit/>
+          </a:bodyPr>
+          <a:lstStyle/>
+          <a:p>
+            <a:pPr algn="ctr"/>
+            <a:r>
+              <a:rPr sz="1600" b="1">
+                <a:solidFill>
+                  <a:srgbClr val="0F766E"/>
+                </a:solidFill>
+                <a:latin typeface="Arial"/>
+              </a:rPr>
+              <a:t>24 columnas crudas  →  93 features listas para modelar</a:t>
             </a:r>
           </a:p>
         </p:txBody>

</xml_diff>